<commit_message>
Created Iris Species Classifier (3-2-2026)
</commit_message>
<xml_diff>
--- a/House Price Predictor/House Price Predictor.pptx
+++ b/House Price Predictor/House Price Predictor.pptx
@@ -2,13 +2,17 @@
 <file path=ppt/presentation.xml><?xml version="1.0" encoding="utf-8"?>
 <p:presentation xmlns:a="http://schemas.openxmlformats.org/drawingml/2006/main" xmlns:r="http://schemas.openxmlformats.org/officeDocument/2006/relationships" xmlns:p="http://schemas.openxmlformats.org/presentationml/2006/main" saveSubsetFonts="1">
   <p:sldMasterIdLst>
-    <p:sldMasterId id="2147483648" r:id="rId1"/>
+    <p:sldMasterId id="2147483660" r:id="rId1"/>
   </p:sldMasterIdLst>
   <p:sldIdLst>
     <p:sldId id="256" r:id="rId2"/>
     <p:sldId id="257" r:id="rId3"/>
     <p:sldId id="258" r:id="rId4"/>
     <p:sldId id="259" r:id="rId5"/>
+    <p:sldId id="260" r:id="rId6"/>
+    <p:sldId id="261" r:id="rId7"/>
+    <p:sldId id="262" r:id="rId8"/>
+    <p:sldId id="263" r:id="rId9"/>
   </p:sldIdLst>
   <p:sldSz cx="12192000" cy="6858000"/>
   <p:notesSz cx="6858000" cy="9144000"/>
@@ -107,6 +111,11 @@
       </a:defRPr>
     </a:lvl9pPr>
   </p:defaultTextStyle>
+  <p:extLst>
+    <p:ext uri="{EFAFB233-063F-42B5-8137-9DF3F51BA10A}">
+      <p15:sldGuideLst xmlns:p15="http://schemas.microsoft.com/office/powerpoint/2012/main"/>
+    </p:ext>
+  </p:extLst>
 </p:presentation>
 </file>
 
@@ -132,7 +141,7 @@
           <p:cNvPr id="2" name="Title 1">
             <a:extLst>
               <a:ext uri="{FF2B5EF4-FFF2-40B4-BE49-F238E27FC236}">
-                <a16:creationId xmlns:a16="http://schemas.microsoft.com/office/drawing/2014/main" id="{D5E1C4F6-EB49-29C9-213C-F50E873080FE}"/>
+                <a16:creationId xmlns:a16="http://schemas.microsoft.com/office/drawing/2014/main" id="{AA1E38A4-3AAF-5609-E742-136430E6DFF5}"/>
               </a:ext>
             </a:extLst>
           </p:cNvPr>
@@ -169,7 +178,7 @@
           <p:cNvPr id="3" name="Subtitle 2">
             <a:extLst>
               <a:ext uri="{FF2B5EF4-FFF2-40B4-BE49-F238E27FC236}">
-                <a16:creationId xmlns:a16="http://schemas.microsoft.com/office/drawing/2014/main" id="{F785796D-6CD3-1C9E-6787-E74B2A644FB1}"/>
+                <a16:creationId xmlns:a16="http://schemas.microsoft.com/office/drawing/2014/main" id="{73FC3261-0C9F-7A88-202C-4C112DCB8954}"/>
               </a:ext>
             </a:extLst>
           </p:cNvPr>
@@ -239,7 +248,7 @@
           <p:cNvPr id="4" name="Date Placeholder 3">
             <a:extLst>
               <a:ext uri="{FF2B5EF4-FFF2-40B4-BE49-F238E27FC236}">
-                <a16:creationId xmlns:a16="http://schemas.microsoft.com/office/drawing/2014/main" id="{7D6C36E7-3492-8DA0-4708-7546EAB3FF68}"/>
+                <a16:creationId xmlns:a16="http://schemas.microsoft.com/office/drawing/2014/main" id="{A2901238-71EA-DF60-165A-DF584E35AD4A}"/>
               </a:ext>
             </a:extLst>
           </p:cNvPr>
@@ -268,7 +277,7 @@
           <p:cNvPr id="5" name="Footer Placeholder 4">
             <a:extLst>
               <a:ext uri="{FF2B5EF4-FFF2-40B4-BE49-F238E27FC236}">
-                <a16:creationId xmlns:a16="http://schemas.microsoft.com/office/drawing/2014/main" id="{E0C46A0B-66C0-37AC-998F-92FFA1108BBE}"/>
+                <a16:creationId xmlns:a16="http://schemas.microsoft.com/office/drawing/2014/main" id="{1DE0787A-3FCC-ECF5-B1AC-8A7DDFB57D6A}"/>
               </a:ext>
             </a:extLst>
           </p:cNvPr>
@@ -293,7 +302,7 @@
           <p:cNvPr id="6" name="Slide Number Placeholder 5">
             <a:extLst>
               <a:ext uri="{FF2B5EF4-FFF2-40B4-BE49-F238E27FC236}">
-                <a16:creationId xmlns:a16="http://schemas.microsoft.com/office/drawing/2014/main" id="{82D3EE79-723A-A52B-7DB2-1C763DC10838}"/>
+                <a16:creationId xmlns:a16="http://schemas.microsoft.com/office/drawing/2014/main" id="{AEA51B01-6CE5-D940-C110-B5D90CEF56C1}"/>
               </a:ext>
             </a:extLst>
           </p:cNvPr>
@@ -320,7 +329,7 @@
     </p:spTree>
     <p:extLst>
       <p:ext uri="{BB962C8B-B14F-4D97-AF65-F5344CB8AC3E}">
-        <p14:creationId xmlns:p14="http://schemas.microsoft.com/office/powerpoint/2010/main" val="48482197"/>
+        <p14:creationId xmlns:p14="http://schemas.microsoft.com/office/powerpoint/2010/main" val="332990726"/>
       </p:ext>
     </p:extLst>
   </p:cSld>
@@ -352,7 +361,7 @@
           <p:cNvPr id="2" name="Title 1">
             <a:extLst>
               <a:ext uri="{FF2B5EF4-FFF2-40B4-BE49-F238E27FC236}">
-                <a16:creationId xmlns:a16="http://schemas.microsoft.com/office/drawing/2014/main" id="{CFB627C6-5D17-D892-5CA5-C9694FC24FA3}"/>
+                <a16:creationId xmlns:a16="http://schemas.microsoft.com/office/drawing/2014/main" id="{A414F322-DEC4-F1E7-7B2E-7A44DA5BD893}"/>
               </a:ext>
             </a:extLst>
           </p:cNvPr>
@@ -380,7 +389,7 @@
           <p:cNvPr id="3" name="Vertical Text Placeholder 2">
             <a:extLst>
               <a:ext uri="{FF2B5EF4-FFF2-40B4-BE49-F238E27FC236}">
-                <a16:creationId xmlns:a16="http://schemas.microsoft.com/office/drawing/2014/main" id="{5B0930A4-9765-5228-B066-E54C53C62270}"/>
+                <a16:creationId xmlns:a16="http://schemas.microsoft.com/office/drawing/2014/main" id="{D520C731-F0F7-2E4E-0FBE-133DC76F3D73}"/>
               </a:ext>
             </a:extLst>
           </p:cNvPr>
@@ -437,7 +446,7 @@
           <p:cNvPr id="4" name="Date Placeholder 3">
             <a:extLst>
               <a:ext uri="{FF2B5EF4-FFF2-40B4-BE49-F238E27FC236}">
-                <a16:creationId xmlns:a16="http://schemas.microsoft.com/office/drawing/2014/main" id="{2B18F681-E417-5155-45A9-F70792BBE43B}"/>
+                <a16:creationId xmlns:a16="http://schemas.microsoft.com/office/drawing/2014/main" id="{60DC86A8-3F44-416D-3E1C-EBD923C367AF}"/>
               </a:ext>
             </a:extLst>
           </p:cNvPr>
@@ -466,7 +475,7 @@
           <p:cNvPr id="5" name="Footer Placeholder 4">
             <a:extLst>
               <a:ext uri="{FF2B5EF4-FFF2-40B4-BE49-F238E27FC236}">
-                <a16:creationId xmlns:a16="http://schemas.microsoft.com/office/drawing/2014/main" id="{3D6E2CCE-5B73-2F10-ACBA-86DF7220A2A2}"/>
+                <a16:creationId xmlns:a16="http://schemas.microsoft.com/office/drawing/2014/main" id="{62BC6FF5-2451-25BD-098D-09D1AABAEDED}"/>
               </a:ext>
             </a:extLst>
           </p:cNvPr>
@@ -491,7 +500,7 @@
           <p:cNvPr id="6" name="Slide Number Placeholder 5">
             <a:extLst>
               <a:ext uri="{FF2B5EF4-FFF2-40B4-BE49-F238E27FC236}">
-                <a16:creationId xmlns:a16="http://schemas.microsoft.com/office/drawing/2014/main" id="{8A1E6835-E325-E32E-B5CD-47F8000BBAEC}"/>
+                <a16:creationId xmlns:a16="http://schemas.microsoft.com/office/drawing/2014/main" id="{21B7D20B-FE7B-1347-55B0-F6FAC89D8052}"/>
               </a:ext>
             </a:extLst>
           </p:cNvPr>
@@ -518,7 +527,7 @@
     </p:spTree>
     <p:extLst>
       <p:ext uri="{BB962C8B-B14F-4D97-AF65-F5344CB8AC3E}">
-        <p14:creationId xmlns:p14="http://schemas.microsoft.com/office/powerpoint/2010/main" val="2482600821"/>
+        <p14:creationId xmlns:p14="http://schemas.microsoft.com/office/powerpoint/2010/main" val="2107034637"/>
       </p:ext>
     </p:extLst>
   </p:cSld>
@@ -550,7 +559,7 @@
           <p:cNvPr id="2" name="Vertical Title 1">
             <a:extLst>
               <a:ext uri="{FF2B5EF4-FFF2-40B4-BE49-F238E27FC236}">
-                <a16:creationId xmlns:a16="http://schemas.microsoft.com/office/drawing/2014/main" id="{0B511446-2227-9690-8966-60198D6EE4D3}"/>
+                <a16:creationId xmlns:a16="http://schemas.microsoft.com/office/drawing/2014/main" id="{FC897E5C-E26D-3F03-1F25-55D4479C2A72}"/>
               </a:ext>
             </a:extLst>
           </p:cNvPr>
@@ -583,7 +592,7 @@
           <p:cNvPr id="3" name="Vertical Text Placeholder 2">
             <a:extLst>
               <a:ext uri="{FF2B5EF4-FFF2-40B4-BE49-F238E27FC236}">
-                <a16:creationId xmlns:a16="http://schemas.microsoft.com/office/drawing/2014/main" id="{F3BD3381-5C20-2777-E684-2812D5EC6C83}"/>
+                <a16:creationId xmlns:a16="http://schemas.microsoft.com/office/drawing/2014/main" id="{4162A060-439A-4845-C13E-A21620B6D5C4}"/>
               </a:ext>
             </a:extLst>
           </p:cNvPr>
@@ -645,7 +654,7 @@
           <p:cNvPr id="4" name="Date Placeholder 3">
             <a:extLst>
               <a:ext uri="{FF2B5EF4-FFF2-40B4-BE49-F238E27FC236}">
-                <a16:creationId xmlns:a16="http://schemas.microsoft.com/office/drawing/2014/main" id="{D4A067FD-4A11-1449-1910-32C168474446}"/>
+                <a16:creationId xmlns:a16="http://schemas.microsoft.com/office/drawing/2014/main" id="{0AA05F69-62F0-DC67-3BAD-28D8024CFEF3}"/>
               </a:ext>
             </a:extLst>
           </p:cNvPr>
@@ -674,7 +683,7 @@
           <p:cNvPr id="5" name="Footer Placeholder 4">
             <a:extLst>
               <a:ext uri="{FF2B5EF4-FFF2-40B4-BE49-F238E27FC236}">
-                <a16:creationId xmlns:a16="http://schemas.microsoft.com/office/drawing/2014/main" id="{AD5DBCA5-887C-FF13-8C94-9286A718F96D}"/>
+                <a16:creationId xmlns:a16="http://schemas.microsoft.com/office/drawing/2014/main" id="{34D44618-D176-1A45-31EF-15ECBC7AA19C}"/>
               </a:ext>
             </a:extLst>
           </p:cNvPr>
@@ -699,7 +708,7 @@
           <p:cNvPr id="6" name="Slide Number Placeholder 5">
             <a:extLst>
               <a:ext uri="{FF2B5EF4-FFF2-40B4-BE49-F238E27FC236}">
-                <a16:creationId xmlns:a16="http://schemas.microsoft.com/office/drawing/2014/main" id="{321C8DC5-FE5C-E0D7-88A1-8A72C4DF4876}"/>
+                <a16:creationId xmlns:a16="http://schemas.microsoft.com/office/drawing/2014/main" id="{DA5498A4-8BD7-1EC6-A5BA-403D12C470D1}"/>
               </a:ext>
             </a:extLst>
           </p:cNvPr>
@@ -726,7 +735,7 @@
     </p:spTree>
     <p:extLst>
       <p:ext uri="{BB962C8B-B14F-4D97-AF65-F5344CB8AC3E}">
-        <p14:creationId xmlns:p14="http://schemas.microsoft.com/office/powerpoint/2010/main" val="1440922195"/>
+        <p14:creationId xmlns:p14="http://schemas.microsoft.com/office/powerpoint/2010/main" val="3990996693"/>
       </p:ext>
     </p:extLst>
   </p:cSld>
@@ -758,7 +767,7 @@
           <p:cNvPr id="2" name="Title 1">
             <a:extLst>
               <a:ext uri="{FF2B5EF4-FFF2-40B4-BE49-F238E27FC236}">
-                <a16:creationId xmlns:a16="http://schemas.microsoft.com/office/drawing/2014/main" id="{093882D9-2131-76DB-F462-15DDEBDF9366}"/>
+                <a16:creationId xmlns:a16="http://schemas.microsoft.com/office/drawing/2014/main" id="{823B5126-4A9E-3FC6-ABDE-D04B7F930FE1}"/>
               </a:ext>
             </a:extLst>
           </p:cNvPr>
@@ -786,7 +795,7 @@
           <p:cNvPr id="3" name="Content Placeholder 2">
             <a:extLst>
               <a:ext uri="{FF2B5EF4-FFF2-40B4-BE49-F238E27FC236}">
-                <a16:creationId xmlns:a16="http://schemas.microsoft.com/office/drawing/2014/main" id="{E49E5642-72F3-E13C-E9C9-6BA2765F15D5}"/>
+                <a16:creationId xmlns:a16="http://schemas.microsoft.com/office/drawing/2014/main" id="{98FA3737-F9F6-9791-9D9F-DD567176F0E4}"/>
               </a:ext>
             </a:extLst>
           </p:cNvPr>
@@ -843,7 +852,7 @@
           <p:cNvPr id="4" name="Date Placeholder 3">
             <a:extLst>
               <a:ext uri="{FF2B5EF4-FFF2-40B4-BE49-F238E27FC236}">
-                <a16:creationId xmlns:a16="http://schemas.microsoft.com/office/drawing/2014/main" id="{58CEF87C-C487-1C00-0B9A-3624A1B64DF1}"/>
+                <a16:creationId xmlns:a16="http://schemas.microsoft.com/office/drawing/2014/main" id="{C0608A33-D14F-AF18-21EC-E7C273E5FD34}"/>
               </a:ext>
             </a:extLst>
           </p:cNvPr>
@@ -872,7 +881,7 @@
           <p:cNvPr id="5" name="Footer Placeholder 4">
             <a:extLst>
               <a:ext uri="{FF2B5EF4-FFF2-40B4-BE49-F238E27FC236}">
-                <a16:creationId xmlns:a16="http://schemas.microsoft.com/office/drawing/2014/main" id="{D650ECA9-3B6E-7F0A-EFC0-A6A85505EC60}"/>
+                <a16:creationId xmlns:a16="http://schemas.microsoft.com/office/drawing/2014/main" id="{67AAAC62-47B9-12C0-94C7-CD7B4F42DF9D}"/>
               </a:ext>
             </a:extLst>
           </p:cNvPr>
@@ -897,7 +906,7 @@
           <p:cNvPr id="6" name="Slide Number Placeholder 5">
             <a:extLst>
               <a:ext uri="{FF2B5EF4-FFF2-40B4-BE49-F238E27FC236}">
-                <a16:creationId xmlns:a16="http://schemas.microsoft.com/office/drawing/2014/main" id="{C1EAFA3B-8E41-8ECB-D056-556FD5C35715}"/>
+                <a16:creationId xmlns:a16="http://schemas.microsoft.com/office/drawing/2014/main" id="{598CC54D-B6E4-2B36-FDE8-65A0E11AD8FC}"/>
               </a:ext>
             </a:extLst>
           </p:cNvPr>
@@ -924,7 +933,7 @@
     </p:spTree>
     <p:extLst>
       <p:ext uri="{BB962C8B-B14F-4D97-AF65-F5344CB8AC3E}">
-        <p14:creationId xmlns:p14="http://schemas.microsoft.com/office/powerpoint/2010/main" val="3185513096"/>
+        <p14:creationId xmlns:p14="http://schemas.microsoft.com/office/powerpoint/2010/main" val="2617733216"/>
       </p:ext>
     </p:extLst>
   </p:cSld>
@@ -956,7 +965,7 @@
           <p:cNvPr id="2" name="Title 1">
             <a:extLst>
               <a:ext uri="{FF2B5EF4-FFF2-40B4-BE49-F238E27FC236}">
-                <a16:creationId xmlns:a16="http://schemas.microsoft.com/office/drawing/2014/main" id="{FA054F6E-8979-C55E-EF96-C8DDFE1DDAA5}"/>
+                <a16:creationId xmlns:a16="http://schemas.microsoft.com/office/drawing/2014/main" id="{57B55822-B31A-4942-7588-68DDB1F5F1DA}"/>
               </a:ext>
             </a:extLst>
           </p:cNvPr>
@@ -993,7 +1002,7 @@
           <p:cNvPr id="3" name="Text Placeholder 2">
             <a:extLst>
               <a:ext uri="{FF2B5EF4-FFF2-40B4-BE49-F238E27FC236}">
-                <a16:creationId xmlns:a16="http://schemas.microsoft.com/office/drawing/2014/main" id="{C4F47634-9C7B-60CC-28C1-EE22EBBA1755}"/>
+                <a16:creationId xmlns:a16="http://schemas.microsoft.com/office/drawing/2014/main" id="{6F2BBA6C-FA07-9AC7-941D-FF3354632768}"/>
               </a:ext>
             </a:extLst>
           </p:cNvPr>
@@ -1118,7 +1127,7 @@
           <p:cNvPr id="4" name="Date Placeholder 3">
             <a:extLst>
               <a:ext uri="{FF2B5EF4-FFF2-40B4-BE49-F238E27FC236}">
-                <a16:creationId xmlns:a16="http://schemas.microsoft.com/office/drawing/2014/main" id="{8A5030B9-B331-A785-ADBA-F365366A1B39}"/>
+                <a16:creationId xmlns:a16="http://schemas.microsoft.com/office/drawing/2014/main" id="{B51BA18C-3739-1A10-F0BE-96A223536F51}"/>
               </a:ext>
             </a:extLst>
           </p:cNvPr>
@@ -1147,7 +1156,7 @@
           <p:cNvPr id="5" name="Footer Placeholder 4">
             <a:extLst>
               <a:ext uri="{FF2B5EF4-FFF2-40B4-BE49-F238E27FC236}">
-                <a16:creationId xmlns:a16="http://schemas.microsoft.com/office/drawing/2014/main" id="{479A16C9-83D9-6411-885E-6FA395C6A314}"/>
+                <a16:creationId xmlns:a16="http://schemas.microsoft.com/office/drawing/2014/main" id="{37FA4C99-49B5-C6E4-7500-8C1F4628ACA5}"/>
               </a:ext>
             </a:extLst>
           </p:cNvPr>
@@ -1172,7 +1181,7 @@
           <p:cNvPr id="6" name="Slide Number Placeholder 5">
             <a:extLst>
               <a:ext uri="{FF2B5EF4-FFF2-40B4-BE49-F238E27FC236}">
-                <a16:creationId xmlns:a16="http://schemas.microsoft.com/office/drawing/2014/main" id="{0F6670FF-98FE-D07D-87D8-6C1EC0690EB3}"/>
+                <a16:creationId xmlns:a16="http://schemas.microsoft.com/office/drawing/2014/main" id="{5F126494-D792-0AE3-EB5D-B29727E24F1C}"/>
               </a:ext>
             </a:extLst>
           </p:cNvPr>
@@ -1199,7 +1208,7 @@
     </p:spTree>
     <p:extLst>
       <p:ext uri="{BB962C8B-B14F-4D97-AF65-F5344CB8AC3E}">
-        <p14:creationId xmlns:p14="http://schemas.microsoft.com/office/powerpoint/2010/main" val="1651868139"/>
+        <p14:creationId xmlns:p14="http://schemas.microsoft.com/office/powerpoint/2010/main" val="3261632823"/>
       </p:ext>
     </p:extLst>
   </p:cSld>
@@ -1231,7 +1240,7 @@
           <p:cNvPr id="2" name="Title 1">
             <a:extLst>
               <a:ext uri="{FF2B5EF4-FFF2-40B4-BE49-F238E27FC236}">
-                <a16:creationId xmlns:a16="http://schemas.microsoft.com/office/drawing/2014/main" id="{EA30BFF2-11C8-5836-D951-E4D86AB0B2EF}"/>
+                <a16:creationId xmlns:a16="http://schemas.microsoft.com/office/drawing/2014/main" id="{6594BF97-E5AD-C8C0-181E-FAD1F3EBDB7A}"/>
               </a:ext>
             </a:extLst>
           </p:cNvPr>
@@ -1259,7 +1268,7 @@
           <p:cNvPr id="3" name="Content Placeholder 2">
             <a:extLst>
               <a:ext uri="{FF2B5EF4-FFF2-40B4-BE49-F238E27FC236}">
-                <a16:creationId xmlns:a16="http://schemas.microsoft.com/office/drawing/2014/main" id="{C8E2777B-F683-D046-2C44-3B1A0627F25C}"/>
+                <a16:creationId xmlns:a16="http://schemas.microsoft.com/office/drawing/2014/main" id="{D52E70D0-04BF-C98E-5227-569016CEDBF2}"/>
               </a:ext>
             </a:extLst>
           </p:cNvPr>
@@ -1321,7 +1330,7 @@
           <p:cNvPr id="4" name="Content Placeholder 3">
             <a:extLst>
               <a:ext uri="{FF2B5EF4-FFF2-40B4-BE49-F238E27FC236}">
-                <a16:creationId xmlns:a16="http://schemas.microsoft.com/office/drawing/2014/main" id="{972903F0-1F70-0FAA-2C99-30B8CB08D927}"/>
+                <a16:creationId xmlns:a16="http://schemas.microsoft.com/office/drawing/2014/main" id="{362FCF83-BCF4-A7E2-CF5B-B76769A24119}"/>
               </a:ext>
             </a:extLst>
           </p:cNvPr>
@@ -1383,7 +1392,7 @@
           <p:cNvPr id="5" name="Date Placeholder 4">
             <a:extLst>
               <a:ext uri="{FF2B5EF4-FFF2-40B4-BE49-F238E27FC236}">
-                <a16:creationId xmlns:a16="http://schemas.microsoft.com/office/drawing/2014/main" id="{E4708BE8-3EBE-9D03-697C-2B1D8711DE5A}"/>
+                <a16:creationId xmlns:a16="http://schemas.microsoft.com/office/drawing/2014/main" id="{686E872F-DDA8-2602-51D9-98A698639AB9}"/>
               </a:ext>
             </a:extLst>
           </p:cNvPr>
@@ -1412,7 +1421,7 @@
           <p:cNvPr id="6" name="Footer Placeholder 5">
             <a:extLst>
               <a:ext uri="{FF2B5EF4-FFF2-40B4-BE49-F238E27FC236}">
-                <a16:creationId xmlns:a16="http://schemas.microsoft.com/office/drawing/2014/main" id="{DF0606F3-90E3-618D-21A7-54650310AA43}"/>
+                <a16:creationId xmlns:a16="http://schemas.microsoft.com/office/drawing/2014/main" id="{F4AEEA56-91B0-9605-7D17-F0B85319B09E}"/>
               </a:ext>
             </a:extLst>
           </p:cNvPr>
@@ -1437,7 +1446,7 @@
           <p:cNvPr id="7" name="Slide Number Placeholder 6">
             <a:extLst>
               <a:ext uri="{FF2B5EF4-FFF2-40B4-BE49-F238E27FC236}">
-                <a16:creationId xmlns:a16="http://schemas.microsoft.com/office/drawing/2014/main" id="{4E5E6795-6855-74A7-8040-5534B6362AEA}"/>
+                <a16:creationId xmlns:a16="http://schemas.microsoft.com/office/drawing/2014/main" id="{258167CA-22B0-E4A5-8FD6-D1EAE9E64B0B}"/>
               </a:ext>
             </a:extLst>
           </p:cNvPr>
@@ -1464,7 +1473,7 @@
     </p:spTree>
     <p:extLst>
       <p:ext uri="{BB962C8B-B14F-4D97-AF65-F5344CB8AC3E}">
-        <p14:creationId xmlns:p14="http://schemas.microsoft.com/office/powerpoint/2010/main" val="2944735673"/>
+        <p14:creationId xmlns:p14="http://schemas.microsoft.com/office/powerpoint/2010/main" val="3852200708"/>
       </p:ext>
     </p:extLst>
   </p:cSld>
@@ -1496,7 +1505,7 @@
           <p:cNvPr id="2" name="Title 1">
             <a:extLst>
               <a:ext uri="{FF2B5EF4-FFF2-40B4-BE49-F238E27FC236}">
-                <a16:creationId xmlns:a16="http://schemas.microsoft.com/office/drawing/2014/main" id="{628B22A7-CA78-DEF3-0C3E-7D588782D869}"/>
+                <a16:creationId xmlns:a16="http://schemas.microsoft.com/office/drawing/2014/main" id="{DE22A6CB-6412-07EC-A78D-09B7DBE01BA1}"/>
               </a:ext>
             </a:extLst>
           </p:cNvPr>
@@ -1529,7 +1538,7 @@
           <p:cNvPr id="3" name="Text Placeholder 2">
             <a:extLst>
               <a:ext uri="{FF2B5EF4-FFF2-40B4-BE49-F238E27FC236}">
-                <a16:creationId xmlns:a16="http://schemas.microsoft.com/office/drawing/2014/main" id="{587FCFF4-9FB5-DF57-8FFE-FF53C1B337DC}"/>
+                <a16:creationId xmlns:a16="http://schemas.microsoft.com/office/drawing/2014/main" id="{31E03CC3-87B2-A545-6164-FE0871D9A75F}"/>
               </a:ext>
             </a:extLst>
           </p:cNvPr>
@@ -1600,7 +1609,7 @@
           <p:cNvPr id="4" name="Content Placeholder 3">
             <a:extLst>
               <a:ext uri="{FF2B5EF4-FFF2-40B4-BE49-F238E27FC236}">
-                <a16:creationId xmlns:a16="http://schemas.microsoft.com/office/drawing/2014/main" id="{1529B687-D203-08EF-4CB8-8BBF488EB0EE}"/>
+                <a16:creationId xmlns:a16="http://schemas.microsoft.com/office/drawing/2014/main" id="{FBB241D7-4D23-0987-7C33-432F926F9E18}"/>
               </a:ext>
             </a:extLst>
           </p:cNvPr>
@@ -1662,7 +1671,7 @@
           <p:cNvPr id="5" name="Text Placeholder 4">
             <a:extLst>
               <a:ext uri="{FF2B5EF4-FFF2-40B4-BE49-F238E27FC236}">
-                <a16:creationId xmlns:a16="http://schemas.microsoft.com/office/drawing/2014/main" id="{7C82CA31-4EC2-5D07-7FF6-280DFDC075F0}"/>
+                <a16:creationId xmlns:a16="http://schemas.microsoft.com/office/drawing/2014/main" id="{1E110EF0-0B5F-93CA-7E9E-B6030A170773}"/>
               </a:ext>
             </a:extLst>
           </p:cNvPr>
@@ -1733,7 +1742,7 @@
           <p:cNvPr id="6" name="Content Placeholder 5">
             <a:extLst>
               <a:ext uri="{FF2B5EF4-FFF2-40B4-BE49-F238E27FC236}">
-                <a16:creationId xmlns:a16="http://schemas.microsoft.com/office/drawing/2014/main" id="{423B0495-B308-1DB2-06D6-56E0E572AA29}"/>
+                <a16:creationId xmlns:a16="http://schemas.microsoft.com/office/drawing/2014/main" id="{814B075C-ED06-80A6-3DD4-4BC87C73E2A8}"/>
               </a:ext>
             </a:extLst>
           </p:cNvPr>
@@ -1795,7 +1804,7 @@
           <p:cNvPr id="7" name="Date Placeholder 6">
             <a:extLst>
               <a:ext uri="{FF2B5EF4-FFF2-40B4-BE49-F238E27FC236}">
-                <a16:creationId xmlns:a16="http://schemas.microsoft.com/office/drawing/2014/main" id="{36C4000D-5E57-11E6-F288-444F75E29D6D}"/>
+                <a16:creationId xmlns:a16="http://schemas.microsoft.com/office/drawing/2014/main" id="{32AC9168-A266-1968-DEF4-84DB6695DEB3}"/>
               </a:ext>
             </a:extLst>
           </p:cNvPr>
@@ -1824,7 +1833,7 @@
           <p:cNvPr id="8" name="Footer Placeholder 7">
             <a:extLst>
               <a:ext uri="{FF2B5EF4-FFF2-40B4-BE49-F238E27FC236}">
-                <a16:creationId xmlns:a16="http://schemas.microsoft.com/office/drawing/2014/main" id="{DFFE83C6-C6F8-ED03-93BB-6A74610969CA}"/>
+                <a16:creationId xmlns:a16="http://schemas.microsoft.com/office/drawing/2014/main" id="{ED3EC190-3057-7F8D-2B6A-9DE497718496}"/>
               </a:ext>
             </a:extLst>
           </p:cNvPr>
@@ -1849,7 +1858,7 @@
           <p:cNvPr id="9" name="Slide Number Placeholder 8">
             <a:extLst>
               <a:ext uri="{FF2B5EF4-FFF2-40B4-BE49-F238E27FC236}">
-                <a16:creationId xmlns:a16="http://schemas.microsoft.com/office/drawing/2014/main" id="{46709654-5AA1-1DC7-38BC-7FEAC6C9B9E9}"/>
+                <a16:creationId xmlns:a16="http://schemas.microsoft.com/office/drawing/2014/main" id="{CAAD54FA-0B18-E92B-4365-7AA57E714171}"/>
               </a:ext>
             </a:extLst>
           </p:cNvPr>
@@ -1876,7 +1885,7 @@
     </p:spTree>
     <p:extLst>
       <p:ext uri="{BB962C8B-B14F-4D97-AF65-F5344CB8AC3E}">
-        <p14:creationId xmlns:p14="http://schemas.microsoft.com/office/powerpoint/2010/main" val="3050687716"/>
+        <p14:creationId xmlns:p14="http://schemas.microsoft.com/office/powerpoint/2010/main" val="2384088180"/>
       </p:ext>
     </p:extLst>
   </p:cSld>
@@ -1908,7 +1917,7 @@
           <p:cNvPr id="2" name="Title 1">
             <a:extLst>
               <a:ext uri="{FF2B5EF4-FFF2-40B4-BE49-F238E27FC236}">
-                <a16:creationId xmlns:a16="http://schemas.microsoft.com/office/drawing/2014/main" id="{935AC42C-55DE-E513-4929-3DD1FDA487BA}"/>
+                <a16:creationId xmlns:a16="http://schemas.microsoft.com/office/drawing/2014/main" id="{F473102D-92DE-C6C7-F047-1F35372123EB}"/>
               </a:ext>
             </a:extLst>
           </p:cNvPr>
@@ -1936,7 +1945,7 @@
           <p:cNvPr id="3" name="Date Placeholder 2">
             <a:extLst>
               <a:ext uri="{FF2B5EF4-FFF2-40B4-BE49-F238E27FC236}">
-                <a16:creationId xmlns:a16="http://schemas.microsoft.com/office/drawing/2014/main" id="{4AD621D3-2D47-CFBB-7188-DB2476F0C6D5}"/>
+                <a16:creationId xmlns:a16="http://schemas.microsoft.com/office/drawing/2014/main" id="{3E53E1DF-A9D0-78EE-7911-B7E38F1A0A8F}"/>
               </a:ext>
             </a:extLst>
           </p:cNvPr>
@@ -1965,7 +1974,7 @@
           <p:cNvPr id="4" name="Footer Placeholder 3">
             <a:extLst>
               <a:ext uri="{FF2B5EF4-FFF2-40B4-BE49-F238E27FC236}">
-                <a16:creationId xmlns:a16="http://schemas.microsoft.com/office/drawing/2014/main" id="{03E3C4B8-DCB4-7848-6346-A945E9CBCE1B}"/>
+                <a16:creationId xmlns:a16="http://schemas.microsoft.com/office/drawing/2014/main" id="{51B2DB80-37A4-62F3-4640-2A1661F13E61}"/>
               </a:ext>
             </a:extLst>
           </p:cNvPr>
@@ -1990,7 +1999,7 @@
           <p:cNvPr id="5" name="Slide Number Placeholder 4">
             <a:extLst>
               <a:ext uri="{FF2B5EF4-FFF2-40B4-BE49-F238E27FC236}">
-                <a16:creationId xmlns:a16="http://schemas.microsoft.com/office/drawing/2014/main" id="{7A33BBC5-7FF3-E881-F0D4-AC22315AC0EA}"/>
+                <a16:creationId xmlns:a16="http://schemas.microsoft.com/office/drawing/2014/main" id="{04995265-C404-7060-0774-DBFFDC4A1096}"/>
               </a:ext>
             </a:extLst>
           </p:cNvPr>
@@ -2017,7 +2026,7 @@
     </p:spTree>
     <p:extLst>
       <p:ext uri="{BB962C8B-B14F-4D97-AF65-F5344CB8AC3E}">
-        <p14:creationId xmlns:p14="http://schemas.microsoft.com/office/powerpoint/2010/main" val="1637156437"/>
+        <p14:creationId xmlns:p14="http://schemas.microsoft.com/office/powerpoint/2010/main" val="3103943333"/>
       </p:ext>
     </p:extLst>
   </p:cSld>
@@ -2049,7 +2058,7 @@
           <p:cNvPr id="2" name="Date Placeholder 1">
             <a:extLst>
               <a:ext uri="{FF2B5EF4-FFF2-40B4-BE49-F238E27FC236}">
-                <a16:creationId xmlns:a16="http://schemas.microsoft.com/office/drawing/2014/main" id="{BEF1B98E-E172-9A70-76C2-1FE858C74437}"/>
+                <a16:creationId xmlns:a16="http://schemas.microsoft.com/office/drawing/2014/main" id="{E43E6F33-B95F-9E3C-E7F9-5CF8656B40DF}"/>
               </a:ext>
             </a:extLst>
           </p:cNvPr>
@@ -2078,7 +2087,7 @@
           <p:cNvPr id="3" name="Footer Placeholder 2">
             <a:extLst>
               <a:ext uri="{FF2B5EF4-FFF2-40B4-BE49-F238E27FC236}">
-                <a16:creationId xmlns:a16="http://schemas.microsoft.com/office/drawing/2014/main" id="{2FFC4FB0-DD8C-4A96-CD2E-C7BA6214C345}"/>
+                <a16:creationId xmlns:a16="http://schemas.microsoft.com/office/drawing/2014/main" id="{11EEFFCA-438E-8E54-0278-A6A88CF8C19A}"/>
               </a:ext>
             </a:extLst>
           </p:cNvPr>
@@ -2103,7 +2112,7 @@
           <p:cNvPr id="4" name="Slide Number Placeholder 3">
             <a:extLst>
               <a:ext uri="{FF2B5EF4-FFF2-40B4-BE49-F238E27FC236}">
-                <a16:creationId xmlns:a16="http://schemas.microsoft.com/office/drawing/2014/main" id="{54AC241A-BB8B-64FD-69B3-A3F6D13EF67F}"/>
+                <a16:creationId xmlns:a16="http://schemas.microsoft.com/office/drawing/2014/main" id="{CADA00D4-3ED5-D7B0-CA7D-67FB71E2E3C5}"/>
               </a:ext>
             </a:extLst>
           </p:cNvPr>
@@ -2130,7 +2139,7 @@
     </p:spTree>
     <p:extLst>
       <p:ext uri="{BB962C8B-B14F-4D97-AF65-F5344CB8AC3E}">
-        <p14:creationId xmlns:p14="http://schemas.microsoft.com/office/powerpoint/2010/main" val="4010644906"/>
+        <p14:creationId xmlns:p14="http://schemas.microsoft.com/office/powerpoint/2010/main" val="2239483553"/>
       </p:ext>
     </p:extLst>
   </p:cSld>
@@ -2162,7 +2171,7 @@
           <p:cNvPr id="2" name="Title 1">
             <a:extLst>
               <a:ext uri="{FF2B5EF4-FFF2-40B4-BE49-F238E27FC236}">
-                <a16:creationId xmlns:a16="http://schemas.microsoft.com/office/drawing/2014/main" id="{2F3AF7A2-2BCE-D2C4-3E4C-CAE893468152}"/>
+                <a16:creationId xmlns:a16="http://schemas.microsoft.com/office/drawing/2014/main" id="{1DB36DC3-528F-86E2-7D2D-207564F3CD65}"/>
               </a:ext>
             </a:extLst>
           </p:cNvPr>
@@ -2199,7 +2208,7 @@
           <p:cNvPr id="3" name="Content Placeholder 2">
             <a:extLst>
               <a:ext uri="{FF2B5EF4-FFF2-40B4-BE49-F238E27FC236}">
-                <a16:creationId xmlns:a16="http://schemas.microsoft.com/office/drawing/2014/main" id="{B33A0BDB-C9F7-C893-30A8-5B5ECAB294A1}"/>
+                <a16:creationId xmlns:a16="http://schemas.microsoft.com/office/drawing/2014/main" id="{F8A940F6-387D-1D07-ACAE-A7C81DF2A8A0}"/>
               </a:ext>
             </a:extLst>
           </p:cNvPr>
@@ -2289,7 +2298,7 @@
           <p:cNvPr id="4" name="Text Placeholder 3">
             <a:extLst>
               <a:ext uri="{FF2B5EF4-FFF2-40B4-BE49-F238E27FC236}">
-                <a16:creationId xmlns:a16="http://schemas.microsoft.com/office/drawing/2014/main" id="{84BAB129-8482-BA46-35BC-05E0FE6066B2}"/>
+                <a16:creationId xmlns:a16="http://schemas.microsoft.com/office/drawing/2014/main" id="{639AC274-0BB1-D023-ED34-D8C0F81B5288}"/>
               </a:ext>
             </a:extLst>
           </p:cNvPr>
@@ -2360,7 +2369,7 @@
           <p:cNvPr id="5" name="Date Placeholder 4">
             <a:extLst>
               <a:ext uri="{FF2B5EF4-FFF2-40B4-BE49-F238E27FC236}">
-                <a16:creationId xmlns:a16="http://schemas.microsoft.com/office/drawing/2014/main" id="{0C4BB143-6C41-1A7F-E8D9-C3083DFB3BCD}"/>
+                <a16:creationId xmlns:a16="http://schemas.microsoft.com/office/drawing/2014/main" id="{7C69A271-3A60-937C-2673-78DFDA1FFEE3}"/>
               </a:ext>
             </a:extLst>
           </p:cNvPr>
@@ -2389,7 +2398,7 @@
           <p:cNvPr id="6" name="Footer Placeholder 5">
             <a:extLst>
               <a:ext uri="{FF2B5EF4-FFF2-40B4-BE49-F238E27FC236}">
-                <a16:creationId xmlns:a16="http://schemas.microsoft.com/office/drawing/2014/main" id="{9D16B557-D428-D8B7-6BD6-C5BD415770C8}"/>
+                <a16:creationId xmlns:a16="http://schemas.microsoft.com/office/drawing/2014/main" id="{4E6C95BD-F8A9-8E9A-9AF1-A8F5511A8AF0}"/>
               </a:ext>
             </a:extLst>
           </p:cNvPr>
@@ -2414,7 +2423,7 @@
           <p:cNvPr id="7" name="Slide Number Placeholder 6">
             <a:extLst>
               <a:ext uri="{FF2B5EF4-FFF2-40B4-BE49-F238E27FC236}">
-                <a16:creationId xmlns:a16="http://schemas.microsoft.com/office/drawing/2014/main" id="{8249D238-ED0B-AC52-A8CA-E36920A4F122}"/>
+                <a16:creationId xmlns:a16="http://schemas.microsoft.com/office/drawing/2014/main" id="{935F3AC9-A753-65EE-18EB-93D6D5F014AF}"/>
               </a:ext>
             </a:extLst>
           </p:cNvPr>
@@ -2441,7 +2450,7 @@
     </p:spTree>
     <p:extLst>
       <p:ext uri="{BB962C8B-B14F-4D97-AF65-F5344CB8AC3E}">
-        <p14:creationId xmlns:p14="http://schemas.microsoft.com/office/powerpoint/2010/main" val="432152743"/>
+        <p14:creationId xmlns:p14="http://schemas.microsoft.com/office/powerpoint/2010/main" val="3736966893"/>
       </p:ext>
     </p:extLst>
   </p:cSld>
@@ -2473,7 +2482,7 @@
           <p:cNvPr id="2" name="Title 1">
             <a:extLst>
               <a:ext uri="{FF2B5EF4-FFF2-40B4-BE49-F238E27FC236}">
-                <a16:creationId xmlns:a16="http://schemas.microsoft.com/office/drawing/2014/main" id="{94693774-39B4-BA62-B4F1-1866EFE27241}"/>
+                <a16:creationId xmlns:a16="http://schemas.microsoft.com/office/drawing/2014/main" id="{44DFF68D-0231-0CF4-958D-0D31F85C81A1}"/>
               </a:ext>
             </a:extLst>
           </p:cNvPr>
@@ -2510,7 +2519,7 @@
           <p:cNvPr id="3" name="Picture Placeholder 2">
             <a:extLst>
               <a:ext uri="{FF2B5EF4-FFF2-40B4-BE49-F238E27FC236}">
-                <a16:creationId xmlns:a16="http://schemas.microsoft.com/office/drawing/2014/main" id="{510EE0C5-32DB-5C27-72FE-C445C321FBDE}"/>
+                <a16:creationId xmlns:a16="http://schemas.microsoft.com/office/drawing/2014/main" id="{01350C61-AB47-0DCC-F3D6-2CAD1E0BAEF9}"/>
               </a:ext>
             </a:extLst>
           </p:cNvPr>
@@ -2577,7 +2586,7 @@
           <p:cNvPr id="4" name="Text Placeholder 3">
             <a:extLst>
               <a:ext uri="{FF2B5EF4-FFF2-40B4-BE49-F238E27FC236}">
-                <a16:creationId xmlns:a16="http://schemas.microsoft.com/office/drawing/2014/main" id="{C6BF2DDD-8403-3FE7-FD7F-D4896B00FF12}"/>
+                <a16:creationId xmlns:a16="http://schemas.microsoft.com/office/drawing/2014/main" id="{FF143FE5-4876-5AA3-31CE-7510568AC5F5}"/>
               </a:ext>
             </a:extLst>
           </p:cNvPr>
@@ -2648,7 +2657,7 @@
           <p:cNvPr id="5" name="Date Placeholder 4">
             <a:extLst>
               <a:ext uri="{FF2B5EF4-FFF2-40B4-BE49-F238E27FC236}">
-                <a16:creationId xmlns:a16="http://schemas.microsoft.com/office/drawing/2014/main" id="{F8A2EBD7-68E5-7704-CE3B-A0BA7BB49BE3}"/>
+                <a16:creationId xmlns:a16="http://schemas.microsoft.com/office/drawing/2014/main" id="{EB5110DD-7DC5-1E0C-190F-458D99FDFEDE}"/>
               </a:ext>
             </a:extLst>
           </p:cNvPr>
@@ -2677,7 +2686,7 @@
           <p:cNvPr id="6" name="Footer Placeholder 5">
             <a:extLst>
               <a:ext uri="{FF2B5EF4-FFF2-40B4-BE49-F238E27FC236}">
-                <a16:creationId xmlns:a16="http://schemas.microsoft.com/office/drawing/2014/main" id="{FC86D861-244B-37CD-ACC6-567E3BAECE7A}"/>
+                <a16:creationId xmlns:a16="http://schemas.microsoft.com/office/drawing/2014/main" id="{21547B16-0515-1D2C-DB46-C8B14C37A94E}"/>
               </a:ext>
             </a:extLst>
           </p:cNvPr>
@@ -2702,7 +2711,7 @@
           <p:cNvPr id="7" name="Slide Number Placeholder 6">
             <a:extLst>
               <a:ext uri="{FF2B5EF4-FFF2-40B4-BE49-F238E27FC236}">
-                <a16:creationId xmlns:a16="http://schemas.microsoft.com/office/drawing/2014/main" id="{FB8DDC8F-1538-CB00-C02A-257B9C15C325}"/>
+                <a16:creationId xmlns:a16="http://schemas.microsoft.com/office/drawing/2014/main" id="{85C5B6C8-991E-A160-CD59-D809EC56B97D}"/>
               </a:ext>
             </a:extLst>
           </p:cNvPr>
@@ -2729,7 +2738,7 @@
     </p:spTree>
     <p:extLst>
       <p:ext uri="{BB962C8B-B14F-4D97-AF65-F5344CB8AC3E}">
-        <p14:creationId xmlns:p14="http://schemas.microsoft.com/office/powerpoint/2010/main" val="1935268571"/>
+        <p14:creationId xmlns:p14="http://schemas.microsoft.com/office/powerpoint/2010/main" val="2864514611"/>
       </p:ext>
     </p:extLst>
   </p:cSld>
@@ -2766,7 +2775,7 @@
           <p:cNvPr id="2" name="Title Placeholder 1">
             <a:extLst>
               <a:ext uri="{FF2B5EF4-FFF2-40B4-BE49-F238E27FC236}">
-                <a16:creationId xmlns:a16="http://schemas.microsoft.com/office/drawing/2014/main" id="{7D453B1B-6744-FCED-FB79-3406440BB7B2}"/>
+                <a16:creationId xmlns:a16="http://schemas.microsoft.com/office/drawing/2014/main" id="{BD2171D0-F518-8CF9-DB8D-B918AB6A3F53}"/>
               </a:ext>
             </a:extLst>
           </p:cNvPr>
@@ -2804,7 +2813,7 @@
           <p:cNvPr id="3" name="Text Placeholder 2">
             <a:extLst>
               <a:ext uri="{FF2B5EF4-FFF2-40B4-BE49-F238E27FC236}">
-                <a16:creationId xmlns:a16="http://schemas.microsoft.com/office/drawing/2014/main" id="{3AB3513D-C8AE-9131-FF95-1DC1C56E9688}"/>
+                <a16:creationId xmlns:a16="http://schemas.microsoft.com/office/drawing/2014/main" id="{C49025BF-575E-B285-A0EC-8120959A8987}"/>
               </a:ext>
             </a:extLst>
           </p:cNvPr>
@@ -2871,7 +2880,7 @@
           <p:cNvPr id="4" name="Date Placeholder 3">
             <a:extLst>
               <a:ext uri="{FF2B5EF4-FFF2-40B4-BE49-F238E27FC236}">
-                <a16:creationId xmlns:a16="http://schemas.microsoft.com/office/drawing/2014/main" id="{8C9FE4BF-6F9C-4DBD-A027-E56A19D7BB12}"/>
+                <a16:creationId xmlns:a16="http://schemas.microsoft.com/office/drawing/2014/main" id="{FC6856C3-2F9A-23DD-426B-7C37994A3158}"/>
               </a:ext>
             </a:extLst>
           </p:cNvPr>
@@ -2918,7 +2927,7 @@
           <p:cNvPr id="5" name="Footer Placeholder 4">
             <a:extLst>
               <a:ext uri="{FF2B5EF4-FFF2-40B4-BE49-F238E27FC236}">
-                <a16:creationId xmlns:a16="http://schemas.microsoft.com/office/drawing/2014/main" id="{E9F7A29A-2357-A4FC-BCEE-86DBA1A0FB51}"/>
+                <a16:creationId xmlns:a16="http://schemas.microsoft.com/office/drawing/2014/main" id="{25720220-19AC-8FAB-ED2A-0C6082A2C833}"/>
               </a:ext>
             </a:extLst>
           </p:cNvPr>
@@ -2961,7 +2970,7 @@
           <p:cNvPr id="6" name="Slide Number Placeholder 5">
             <a:extLst>
               <a:ext uri="{FF2B5EF4-FFF2-40B4-BE49-F238E27FC236}">
-                <a16:creationId xmlns:a16="http://schemas.microsoft.com/office/drawing/2014/main" id="{B65FFA3B-9053-4344-20FC-6FCA37BA7D02}"/>
+                <a16:creationId xmlns:a16="http://schemas.microsoft.com/office/drawing/2014/main" id="{721E3E90-42A1-2766-FB6F-308F87957EB1}"/>
               </a:ext>
             </a:extLst>
           </p:cNvPr>
@@ -3006,23 +3015,23 @@
     </p:spTree>
     <p:extLst>
       <p:ext uri="{BB962C8B-B14F-4D97-AF65-F5344CB8AC3E}">
-        <p14:creationId xmlns:p14="http://schemas.microsoft.com/office/powerpoint/2010/main" val="1298288849"/>
+        <p14:creationId xmlns:p14="http://schemas.microsoft.com/office/powerpoint/2010/main" val="4166969719"/>
       </p:ext>
     </p:extLst>
   </p:cSld>
   <p:clrMap bg1="lt1" tx1="dk1" bg2="lt2" tx2="dk2" accent1="accent1" accent2="accent2" accent3="accent3" accent4="accent4" accent5="accent5" accent6="accent6" hlink="hlink" folHlink="folHlink"/>
   <p:sldLayoutIdLst>
-    <p:sldLayoutId id="2147483649" r:id="rId1"/>
-    <p:sldLayoutId id="2147483650" r:id="rId2"/>
-    <p:sldLayoutId id="2147483651" r:id="rId3"/>
-    <p:sldLayoutId id="2147483652" r:id="rId4"/>
-    <p:sldLayoutId id="2147483653" r:id="rId5"/>
-    <p:sldLayoutId id="2147483654" r:id="rId6"/>
-    <p:sldLayoutId id="2147483655" r:id="rId7"/>
-    <p:sldLayoutId id="2147483656" r:id="rId8"/>
-    <p:sldLayoutId id="2147483657" r:id="rId9"/>
-    <p:sldLayoutId id="2147483658" r:id="rId10"/>
-    <p:sldLayoutId id="2147483659" r:id="rId11"/>
+    <p:sldLayoutId id="2147483661" r:id="rId1"/>
+    <p:sldLayoutId id="2147483662" r:id="rId2"/>
+    <p:sldLayoutId id="2147483663" r:id="rId3"/>
+    <p:sldLayoutId id="2147483664" r:id="rId4"/>
+    <p:sldLayoutId id="2147483665" r:id="rId5"/>
+    <p:sldLayoutId id="2147483666" r:id="rId6"/>
+    <p:sldLayoutId id="2147483667" r:id="rId7"/>
+    <p:sldLayoutId id="2147483668" r:id="rId8"/>
+    <p:sldLayoutId id="2147483669" r:id="rId9"/>
+    <p:sldLayoutId id="2147483670" r:id="rId10"/>
+    <p:sldLayoutId id="2147483671" r:id="rId11"/>
   </p:sldLayoutIdLst>
   <p:txStyles>
     <p:titleStyle>
@@ -3340,7 +3349,12 @@
             <p:ph type="ctrTitle"/>
           </p:nvPr>
         </p:nvSpPr>
-        <p:spPr/>
+        <p:spPr>
+          <a:xfrm>
+            <a:off x="1524000" y="2037348"/>
+            <a:ext cx="9144000" cy="991352"/>
+          </a:xfrm>
+        </p:spPr>
         <p:txBody>
           <a:bodyPr/>
           <a:lstStyle/>
@@ -3370,7 +3384,9 @@
         </p:nvSpPr>
         <p:spPr/>
         <p:txBody>
-          <a:bodyPr/>
+          <a:bodyPr>
+            <a:normAutofit lnSpcReduction="10000"/>
+          </a:bodyPr>
           <a:lstStyle/>
           <a:p>
             <a:r>
@@ -3381,13 +3397,19 @@
           <a:p>
             <a:r>
               <a:rPr lang="en-US" dirty="0"/>
-              <a:t>M Haroon Abbas  </a:t>
+              <a:t>From: M Haroon Abbas  </a:t>
             </a:r>
           </a:p>
           <a:p>
             <a:r>
               <a:rPr lang="en-US" dirty="0"/>
               <a:t>2K23/ BLCS/ 38</a:t>
+            </a:r>
+          </a:p>
+          <a:p>
+            <a:r>
+              <a:rPr lang="en-US" dirty="0"/>
+              <a:t>Course Instructor: Dr Fozia Talpur</a:t>
             </a:r>
           </a:p>
         </p:txBody>
@@ -3436,7 +3458,7 @@
         </p:nvSpPr>
         <p:spPr>
           <a:xfrm>
-            <a:off x="4828674" y="136175"/>
+            <a:off x="4828674" y="376806"/>
             <a:ext cx="6096000" cy="584775"/>
           </a:xfrm>
           <a:prstGeom prst="rect">
@@ -3564,7 +3586,7 @@
                 <a:effectLst/>
                 <a:latin typeface="Arial Nova" panose="020F0502020204030204" pitchFamily="34" charset="0"/>
               </a:rPr>
-              <a:t> To Predict House Prices </a:t>
+              <a:t> To Predict House Prices according to given features as input</a:t>
             </a:r>
           </a:p>
           <a:p>
@@ -4034,7 +4056,7 @@
         </p:nvSpPr>
         <p:spPr>
           <a:xfrm>
-            <a:off x="4908816" y="139484"/>
+            <a:off x="4908816" y="258593"/>
             <a:ext cx="2374368" cy="584775"/>
           </a:xfrm>
           <a:prstGeom prst="rect">
@@ -4299,7 +4321,7 @@
       </p:sp>
       <p:pic>
         <p:nvPicPr>
-          <p:cNvPr id="2051" name="Picture 3" descr="Linear Regression Explained with Example &amp; Application">
+          <p:cNvPr id="4" name="Picture 3" descr="Linear Regression Explained with Example &amp; Application">
             <a:extLst>
               <a:ext uri="{FF2B5EF4-FFF2-40B4-BE49-F238E27FC236}">
                 <a16:creationId xmlns:a16="http://schemas.microsoft.com/office/drawing/2014/main" id="{822CEEEA-A5FF-1E79-CEBD-7E4D5C758E1B}"/>
@@ -4326,7 +4348,7 @@
         </p:blipFill>
         <p:spPr bwMode="auto">
           <a:xfrm>
-            <a:off x="6096000" y="1462841"/>
+            <a:off x="6323308" y="1324423"/>
             <a:ext cx="5527729" cy="3932318"/>
           </a:xfrm>
           <a:prstGeom prst="rect">
@@ -4388,7 +4410,7 @@
         </p:nvSpPr>
         <p:spPr>
           <a:xfrm>
-            <a:off x="2374469" y="195042"/>
+            <a:off x="2435137" y="312601"/>
             <a:ext cx="8009395" cy="584775"/>
           </a:xfrm>
           <a:prstGeom prst="rect">
@@ -4427,8 +4449,8 @@
         </p:nvSpPr>
         <p:spPr bwMode="auto">
           <a:xfrm>
-            <a:off x="276386" y="1177055"/>
-            <a:ext cx="11639227" cy="5216813"/>
+            <a:off x="276386" y="3393046"/>
+            <a:ext cx="11639227" cy="784830"/>
           </a:xfrm>
           <a:prstGeom prst="rect">
             <a:avLst/>
@@ -4492,19 +4514,16 @@
               <a:buNone/>
               <a:tabLst/>
             </a:pPr>
-            <a:r>
-              <a:rPr kumimoji="0" lang="en-US" altLang="en-US" sz="2400" b="0" i="0" u="none" strike="noStrike" cap="none" normalizeH="0" baseline="0" dirty="0">
-                <a:ln>
-                  <a:noFill/>
-                </a:ln>
-                <a:solidFill>
-                  <a:schemeClr val="tx1"/>
-                </a:solidFill>
-                <a:effectLst/>
-                <a:latin typeface="Arial Nova" panose="020B0504020202020204" pitchFamily="34" charset="0"/>
-              </a:rPr>
-              <a:t>To know if our model is "good," we use two primary industry-standard metrics:</a:t>
-            </a:r>
+            <a:endParaRPr kumimoji="0" lang="en-US" altLang="en-US" sz="2400" b="0" i="0" u="none" strike="noStrike" cap="none" normalizeH="0" baseline="0" dirty="0">
+              <a:ln>
+                <a:noFill/>
+              </a:ln>
+              <a:solidFill>
+                <a:schemeClr val="tx1"/>
+              </a:solidFill>
+              <a:effectLst/>
+              <a:latin typeface="Arial Nova" panose="020B0504020202020204" pitchFamily="34" charset="0"/>
+            </a:endParaRPr>
           </a:p>
           <a:p>
             <a:pPr marL="0" marR="0" lvl="0" indent="0" algn="l" defTabSz="914400" rtl="0" eaLnBrk="0" fontAlgn="base" latinLnBrk="0" hangingPunct="0">
@@ -4534,49 +4553,121 @@
               <a:latin typeface="Arial Nova" panose="020B0504020202020204" pitchFamily="34" charset="0"/>
             </a:endParaRPr>
           </a:p>
+        </p:txBody>
+      </p:sp>
+      <p:pic>
+        <p:nvPicPr>
+          <p:cNvPr id="3106" name="Picture 34">
+            <a:extLst>
+              <a:ext uri="{FF2B5EF4-FFF2-40B4-BE49-F238E27FC236}">
+                <a16:creationId xmlns:a16="http://schemas.microsoft.com/office/drawing/2014/main" id="{A1A8B6F8-D283-920F-E5E8-5F308BB392C6}"/>
+              </a:ext>
+            </a:extLst>
+          </p:cNvPr>
+          <p:cNvPicPr>
+            <a:picLocks noChangeAspect="1" noChangeArrowheads="1"/>
+          </p:cNvPicPr>
+          <p:nvPr/>
+        </p:nvPicPr>
+        <p:blipFill>
+          <a:blip r:embed="rId2">
+            <a:extLst>
+              <a:ext uri="{28A0092B-C50C-407E-A947-70E740481C1C}">
+                <a14:useLocalDpi xmlns:a14="http://schemas.microsoft.com/office/drawing/2010/main" val="0"/>
+              </a:ext>
+            </a:extLst>
+          </a:blip>
+          <a:srcRect/>
+          <a:stretch>
+            <a:fillRect/>
+          </a:stretch>
+        </p:blipFill>
+        <p:spPr bwMode="auto">
+          <a:xfrm>
+            <a:off x="6091238" y="3424238"/>
+            <a:ext cx="9525" cy="9525"/>
+          </a:xfrm>
+          <a:prstGeom prst="rect">
+            <a:avLst/>
+          </a:prstGeom>
+          <a:noFill/>
+          <a:extLst>
+            <a:ext uri="{909E8E84-426E-40DD-AFC4-6F175D3DCCD1}">
+              <a14:hiddenFill xmlns:a14="http://schemas.microsoft.com/office/drawing/2010/main">
+                <a:solidFill>
+                  <a:srgbClr val="FFFFFF"/>
+                </a:solidFill>
+              </a14:hiddenFill>
+            </a:ext>
+          </a:extLst>
+        </p:spPr>
+      </p:pic>
+      <p:sp>
+        <p:nvSpPr>
+          <p:cNvPr id="2" name="Rectangle 1">
+            <a:extLst>
+              <a:ext uri="{FF2B5EF4-FFF2-40B4-BE49-F238E27FC236}">
+                <a16:creationId xmlns:a16="http://schemas.microsoft.com/office/drawing/2014/main" id="{1A83FFDB-AF17-44D6-0F8E-B0B7129DA51E}"/>
+              </a:ext>
+            </a:extLst>
+          </p:cNvPr>
+          <p:cNvSpPr>
+            <a:spLocks noChangeArrowheads="1"/>
+          </p:cNvSpPr>
+          <p:nvPr/>
+        </p:nvSpPr>
+        <p:spPr bwMode="auto">
+          <a:xfrm>
+            <a:off x="454428" y="1195604"/>
+            <a:ext cx="11461185" cy="3416320"/>
+          </a:xfrm>
+          <a:prstGeom prst="rect">
+            <a:avLst/>
+          </a:prstGeom>
+          <a:noFill/>
+          <a:ln>
+            <a:noFill/>
+          </a:ln>
+          <a:effectLst/>
+          <a:extLst>
+            <a:ext uri="{909E8E84-426E-40DD-AFC4-6F175D3DCCD1}">
+              <a14:hiddenFill xmlns:a14="http://schemas.microsoft.com/office/drawing/2010/main">
+                <a:solidFill>
+                  <a:schemeClr val="accent1"/>
+                </a:solidFill>
+              </a14:hiddenFill>
+            </a:ext>
+            <a:ext uri="{91240B29-F687-4F45-9708-019B960494DF}">
+              <a14:hiddenLine xmlns:a14="http://schemas.microsoft.com/office/drawing/2010/main" w="9525">
+                <a:solidFill>
+                  <a:schemeClr val="tx1"/>
+                </a:solidFill>
+                <a:miter lim="800000"/>
+                <a:headEnd/>
+                <a:tailEnd/>
+              </a14:hiddenLine>
+            </a:ext>
+            <a:ext uri="{AF507438-7753-43E0-B8FC-AC1667EBCBE1}">
+              <a14:hiddenEffects xmlns:a14="http://schemas.microsoft.com/office/drawing/2010/main">
+                <a:effectLst>
+                  <a:outerShdw dist="35921" dir="2700000" algn="ctr" rotWithShape="0">
+                    <a:schemeClr val="bg2"/>
+                  </a:outerShdw>
+                </a:effectLst>
+              </a14:hiddenEffects>
+            </a:ext>
+          </a:extLst>
+        </p:spPr>
+        <p:txBody>
+          <a:bodyPr vert="horz" wrap="square" lIns="91440" tIns="45720" rIns="91440" bIns="45720" numCol="1" anchor="ctr" anchorCtr="0" compatLnSpc="1">
+            <a:prstTxWarp prst="textNoShape">
+              <a:avLst/>
+            </a:prstTxWarp>
+            <a:spAutoFit/>
+          </a:bodyPr>
+          <a:lstStyle/>
           <a:p>
             <a:pPr marL="0" marR="0" lvl="0" indent="0" algn="l" defTabSz="914400" rtl="0" eaLnBrk="0" fontAlgn="base" latinLnBrk="0" hangingPunct="0">
-              <a:lnSpc>
-                <a:spcPct val="100000"/>
-              </a:lnSpc>
-              <a:spcBef>
-                <a:spcPct val="0"/>
-              </a:spcBef>
-              <a:spcAft>
-                <a:spcPct val="0"/>
-              </a:spcAft>
-              <a:buClrTx/>
-              <a:buSzTx/>
-              <a:buFontTx/>
-              <a:buAutoNum type="arabicPeriod"/>
-              <a:tabLst/>
-            </a:pPr>
-            <a:r>
-              <a:rPr kumimoji="0" lang="en-US" altLang="en-US" sz="2400" b="1" i="0" u="none" strike="noStrike" cap="none" normalizeH="0" baseline="0" dirty="0">
-                <a:ln>
-                  <a:noFill/>
-                </a:ln>
-                <a:solidFill>
-                  <a:schemeClr val="tx1"/>
-                </a:solidFill>
-                <a:effectLst/>
-                <a:latin typeface="Arial Nova" panose="020B0504020202020204" pitchFamily="34" charset="0"/>
-              </a:rPr>
-              <a:t> R^2 Score (Coefficient of Determination):</a:t>
-            </a:r>
-            <a:endParaRPr kumimoji="0" lang="en-US" altLang="en-US" sz="2400" b="0" i="0" u="none" strike="noStrike" cap="none" normalizeH="0" baseline="0" dirty="0">
-              <a:ln>
-                <a:noFill/>
-              </a:ln>
-              <a:solidFill>
-                <a:schemeClr val="tx1"/>
-              </a:solidFill>
-              <a:effectLst/>
-              <a:latin typeface="Arial Nova" panose="020B0504020202020204" pitchFamily="34" charset="0"/>
-            </a:endParaRPr>
-          </a:p>
-          <a:p>
-            <a:pPr marL="457200" marR="0" lvl="1" indent="0" algn="l" defTabSz="914400" rtl="0" eaLnBrk="0" fontAlgn="base" latinLnBrk="0" hangingPunct="0">
               <a:lnSpc>
                 <a:spcPct val="100000"/>
               </a:lnSpc>
@@ -4593,6 +4684,19 @@
               <a:tabLst/>
             </a:pPr>
             <a:r>
+              <a:rPr kumimoji="0" lang="en-US" altLang="en-US" sz="2400" b="0" i="0" u="none" strike="noStrike" cap="none" normalizeH="0" baseline="0" dirty="0">
+                <a:ln>
+                  <a:noFill/>
+                </a:ln>
+                <a:solidFill>
+                  <a:schemeClr val="tx1"/>
+                </a:solidFill>
+                <a:effectLst/>
+                <a:latin typeface="Arial" panose="020B0604020202020204" pitchFamily="34" charset="0"/>
+              </a:rPr>
+              <a:t>Since this is a </a:t>
+            </a:r>
+            <a:r>
               <a:rPr kumimoji="0" lang="en-US" altLang="en-US" sz="2400" b="1" i="0" u="none" strike="noStrike" cap="none" normalizeH="0" baseline="0" dirty="0">
                 <a:ln>
                   <a:noFill/>
@@ -4601,9 +4705,9 @@
                   <a:schemeClr val="tx1"/>
                 </a:solidFill>
                 <a:effectLst/>
-                <a:latin typeface="Arial Nova" panose="020B0504020202020204" pitchFamily="34" charset="0"/>
-              </a:rPr>
-              <a:t> What it is:</a:t>
+                <a:latin typeface="Arial" panose="020B0604020202020204" pitchFamily="34" charset="0"/>
+              </a:rPr>
+              <a:t>regression problem</a:t>
             </a:r>
             <a:r>
               <a:rPr kumimoji="0" lang="en-US" altLang="en-US" sz="2400" b="0" i="0" u="none" strike="noStrike" cap="none" normalizeH="0" baseline="0" dirty="0">
@@ -4614,28 +4718,10 @@
                   <a:schemeClr val="tx1"/>
                 </a:solidFill>
                 <a:effectLst/>
-                <a:latin typeface="Arial Nova" panose="020B0504020202020204" pitchFamily="34" charset="0"/>
-              </a:rPr>
-              <a:t> Represents the proportion of variance for the price that's explained by our features.</a:t>
-            </a:r>
-          </a:p>
-          <a:p>
-            <a:pPr marL="457200" marR="0" lvl="1" indent="0" algn="l" defTabSz="914400" rtl="0" eaLnBrk="0" fontAlgn="base" latinLnBrk="0" hangingPunct="0">
-              <a:lnSpc>
-                <a:spcPct val="100000"/>
-              </a:lnSpc>
-              <a:spcBef>
-                <a:spcPct val="0"/>
-              </a:spcBef>
-              <a:spcAft>
-                <a:spcPct val="0"/>
-              </a:spcAft>
-              <a:buClrTx/>
-              <a:buSzTx/>
-              <a:buFontTx/>
-              <a:buChar char="•"/>
-              <a:tabLst/>
-            </a:pPr>
+                <a:latin typeface="Arial" panose="020B0604020202020204" pitchFamily="34" charset="0"/>
+              </a:rPr>
+              <a:t>, we evaluate the model using </a:t>
+            </a:r>
             <a:r>
               <a:rPr kumimoji="0" lang="en-US" altLang="en-US" sz="2400" b="1" i="0" u="none" strike="noStrike" cap="none" normalizeH="0" baseline="0" dirty="0">
                 <a:ln>
@@ -4645,9 +4731,9 @@
                   <a:schemeClr val="tx1"/>
                 </a:solidFill>
                 <a:effectLst/>
-                <a:latin typeface="Arial Nova" panose="020B0504020202020204" pitchFamily="34" charset="0"/>
-              </a:rPr>
-              <a:t> Scale:</a:t>
+                <a:latin typeface="Arial" panose="020B0604020202020204" pitchFamily="34" charset="0"/>
+              </a:rPr>
+              <a:t>regression metrics</a:t>
             </a:r>
             <a:r>
               <a:rPr kumimoji="0" lang="en-US" altLang="en-US" sz="2400" b="0" i="0" u="none" strike="noStrike" cap="none" normalizeH="0" baseline="0" dirty="0">
@@ -4658,83 +4744,13 @@
                   <a:schemeClr val="tx1"/>
                 </a:solidFill>
                 <a:effectLst/>
-                <a:latin typeface="Arial Nova" panose="020B0504020202020204" pitchFamily="34" charset="0"/>
-              </a:rPr>
-              <a:t> 0 to 1.</a:t>
-            </a:r>
-          </a:p>
-          <a:p>
-            <a:pPr marL="457200" marR="0" lvl="1" indent="0" algn="l" defTabSz="914400" rtl="0" eaLnBrk="0" fontAlgn="base" latinLnBrk="0" hangingPunct="0">
-              <a:lnSpc>
-                <a:spcPct val="100000"/>
-              </a:lnSpc>
-              <a:spcBef>
-                <a:spcPct val="0"/>
-              </a:spcBef>
-              <a:spcAft>
-                <a:spcPct val="0"/>
-              </a:spcAft>
-              <a:buClrTx/>
-              <a:buSzTx/>
-              <a:buFontTx/>
-              <a:buChar char="•"/>
-              <a:tabLst/>
-            </a:pPr>
-            <a:r>
-              <a:rPr kumimoji="0" lang="en-US" altLang="en-US" sz="2400" b="1" i="0" u="none" strike="noStrike" cap="none" normalizeH="0" baseline="0" dirty="0">
-                <a:ln>
-                  <a:noFill/>
-                </a:ln>
-                <a:solidFill>
-                  <a:schemeClr val="tx1"/>
-                </a:solidFill>
-                <a:effectLst/>
-                <a:latin typeface="Arial Nova" panose="020B0504020202020204" pitchFamily="34" charset="0"/>
-              </a:rPr>
-              <a:t> Example:</a:t>
-            </a:r>
-            <a:r>
-              <a:rPr kumimoji="0" lang="en-US" altLang="en-US" sz="2400" b="0" i="0" u="none" strike="noStrike" cap="none" normalizeH="0" baseline="0" dirty="0">
-                <a:ln>
-                  <a:noFill/>
-                </a:ln>
-                <a:solidFill>
-                  <a:schemeClr val="tx1"/>
-                </a:solidFill>
-                <a:effectLst/>
-                <a:latin typeface="Arial Nova" panose="020B0504020202020204" pitchFamily="34" charset="0"/>
-              </a:rPr>
-              <a:t> An R^2 of </a:t>
-            </a:r>
-            <a:r>
-              <a:rPr kumimoji="0" lang="en-US" altLang="en-US" sz="2400" b="1" i="0" u="none" strike="noStrike" cap="none" normalizeH="0" baseline="0" dirty="0">
-                <a:ln>
-                  <a:noFill/>
-                </a:ln>
-                <a:solidFill>
-                  <a:schemeClr val="tx1"/>
-                </a:solidFill>
-                <a:effectLst/>
-                <a:latin typeface="Arial Nova" panose="020B0504020202020204" pitchFamily="34" charset="0"/>
-              </a:rPr>
-              <a:t>0.83</a:t>
-            </a:r>
-            <a:r>
-              <a:rPr kumimoji="0" lang="en-US" altLang="en-US" sz="2400" b="0" i="0" u="none" strike="noStrike" cap="none" normalizeH="0" baseline="0" dirty="0">
-                <a:ln>
-                  <a:noFill/>
-                </a:ln>
-                <a:solidFill>
-                  <a:schemeClr val="tx1"/>
-                </a:solidFill>
-                <a:effectLst/>
-                <a:latin typeface="Arial Nova" panose="020B0504020202020204" pitchFamily="34" charset="0"/>
-              </a:rPr>
-              <a:t> means our model explains 83% of the price variations.</a:t>
-            </a:r>
-          </a:p>
-          <a:p>
-            <a:pPr marL="457200" marR="0" lvl="1" indent="0" algn="l" defTabSz="914400" rtl="0" eaLnBrk="0" fontAlgn="base" latinLnBrk="0" hangingPunct="0">
+                <a:latin typeface="Arial" panose="020B0604020202020204" pitchFamily="34" charset="0"/>
+              </a:rPr>
+              <a:t>, not classification metrics.</a:t>
+            </a:r>
+          </a:p>
+          <a:p>
+            <a:pPr marL="0" marR="0" lvl="0" indent="0" algn="l" defTabSz="914400" rtl="0" eaLnBrk="0" fontAlgn="base" latinLnBrk="0" hangingPunct="0">
               <a:lnSpc>
                 <a:spcPct val="100000"/>
               </a:lnSpc>
@@ -4758,7 +4774,7 @@
                 <a:schemeClr val="tx1"/>
               </a:solidFill>
               <a:effectLst/>
-              <a:latin typeface="Arial Nova" panose="020B0504020202020204" pitchFamily="34" charset="0"/>
+              <a:latin typeface="Arial Black" panose="020B0A04020102020204" pitchFamily="34" charset="0"/>
             </a:endParaRPr>
           </a:p>
           <a:p>
@@ -4774,8 +4790,6 @@
               </a:spcAft>
               <a:buClrTx/>
               <a:buSzTx/>
-              <a:buFontTx/>
-              <a:buAutoNum type="arabicPeriod" startAt="2"/>
               <a:tabLst/>
             </a:pPr>
             <a:r>
@@ -4787,23 +4801,13 @@
                   <a:schemeClr val="tx1"/>
                 </a:solidFill>
                 <a:effectLst/>
-                <a:latin typeface="Arial Nova" panose="020B0504020202020204" pitchFamily="34" charset="0"/>
-              </a:rPr>
-              <a:t> RMSE (Root Mean Squared Error):</a:t>
-            </a:r>
-            <a:endParaRPr kumimoji="0" lang="en-US" altLang="en-US" sz="2400" b="0" i="0" u="none" strike="noStrike" cap="none" normalizeH="0" baseline="0" dirty="0">
-              <a:ln>
-                <a:noFill/>
-              </a:ln>
-              <a:solidFill>
-                <a:schemeClr val="tx1"/>
-              </a:solidFill>
-              <a:effectLst/>
-              <a:latin typeface="Arial Nova" panose="020B0504020202020204" pitchFamily="34" charset="0"/>
-            </a:endParaRPr>
-          </a:p>
-          <a:p>
-            <a:pPr marL="457200" marR="0" lvl="1" indent="0" algn="l" defTabSz="914400" rtl="0" eaLnBrk="0" fontAlgn="base" latinLnBrk="0" hangingPunct="0">
+                <a:latin typeface="Arial Black" panose="020B0A04020102020204" pitchFamily="34" charset="0"/>
+              </a:rPr>
+              <a:t>The two primary metrics used are:</a:t>
+            </a:r>
+          </a:p>
+          <a:p>
+            <a:pPr marL="0" marR="0" lvl="0" indent="0" algn="l" defTabSz="914400" rtl="0" eaLnBrk="0" fontAlgn="base" latinLnBrk="0" hangingPunct="0">
               <a:lnSpc>
                 <a:spcPct val="100000"/>
               </a:lnSpc>
@@ -4819,6 +4823,34 @@
               <a:buChar char="•"/>
               <a:tabLst/>
             </a:pPr>
+            <a:endParaRPr kumimoji="0" lang="en-US" altLang="en-US" sz="2400" b="0" i="0" u="none" strike="noStrike" cap="none" normalizeH="0" baseline="0" dirty="0">
+              <a:ln>
+                <a:noFill/>
+              </a:ln>
+              <a:solidFill>
+                <a:schemeClr val="tx1"/>
+              </a:solidFill>
+              <a:effectLst/>
+              <a:latin typeface="Arial" panose="020B0604020202020204" pitchFamily="34" charset="0"/>
+            </a:endParaRPr>
+          </a:p>
+          <a:p>
+            <a:pPr marL="457200" marR="0" lvl="0" indent="-457200" algn="l" defTabSz="914400" rtl="0" eaLnBrk="0" fontAlgn="base" latinLnBrk="0" hangingPunct="0">
+              <a:lnSpc>
+                <a:spcPct val="100000"/>
+              </a:lnSpc>
+              <a:spcBef>
+                <a:spcPct val="0"/>
+              </a:spcBef>
+              <a:spcAft>
+                <a:spcPct val="0"/>
+              </a:spcAft>
+              <a:buClrTx/>
+              <a:buSzTx/>
+              <a:buFont typeface="+mj-lt"/>
+              <a:buAutoNum type="arabicPeriod"/>
+              <a:tabLst/>
+            </a:pPr>
             <a:r>
               <a:rPr kumimoji="0" lang="en-US" altLang="en-US" sz="2400" b="1" i="0" u="none" strike="noStrike" cap="none" normalizeH="0" baseline="0" dirty="0">
                 <a:ln>
@@ -4828,10 +4860,95 @@
                   <a:schemeClr val="tx1"/>
                 </a:solidFill>
                 <a:effectLst/>
-                <a:latin typeface="Arial Nova" panose="020B0504020202020204" pitchFamily="34" charset="0"/>
-              </a:rPr>
-              <a:t> What it is:</a:t>
-            </a:r>
+                <a:latin typeface="Arial" panose="020B0604020202020204" pitchFamily="34" charset="0"/>
+              </a:rPr>
+              <a:t> R² (Coefficient of Determination)</a:t>
+            </a:r>
+            <a:endParaRPr kumimoji="0" lang="en-US" altLang="en-US" sz="2400" b="0" i="0" u="none" strike="noStrike" cap="none" normalizeH="0" baseline="0" dirty="0">
+              <a:ln>
+                <a:noFill/>
+              </a:ln>
+              <a:solidFill>
+                <a:schemeClr val="tx1"/>
+              </a:solidFill>
+              <a:effectLst/>
+              <a:latin typeface="Arial" panose="020B0604020202020204" pitchFamily="34" charset="0"/>
+            </a:endParaRPr>
+          </a:p>
+          <a:p>
+            <a:pPr marL="457200" marR="0" lvl="0" indent="-457200" algn="l" defTabSz="914400" rtl="0" eaLnBrk="0" fontAlgn="base" latinLnBrk="0" hangingPunct="0">
+              <a:lnSpc>
+                <a:spcPct val="100000"/>
+              </a:lnSpc>
+              <a:spcBef>
+                <a:spcPct val="0"/>
+              </a:spcBef>
+              <a:spcAft>
+                <a:spcPct val="0"/>
+              </a:spcAft>
+              <a:buClrTx/>
+              <a:buSzTx/>
+              <a:buFont typeface="+mj-lt"/>
+              <a:buAutoNum type="arabicPeriod"/>
+              <a:tabLst/>
+            </a:pPr>
+            <a:r>
+              <a:rPr kumimoji="0" lang="en-US" altLang="en-US" sz="2400" b="1" i="0" u="none" strike="noStrike" cap="none" normalizeH="0" baseline="0" dirty="0">
+                <a:ln>
+                  <a:noFill/>
+                </a:ln>
+                <a:solidFill>
+                  <a:schemeClr val="tx1"/>
+                </a:solidFill>
+                <a:effectLst/>
+                <a:latin typeface="Arial" panose="020B0604020202020204" pitchFamily="34" charset="0"/>
+              </a:rPr>
+              <a:t> RMSE (Root Mean Squared Error)</a:t>
+            </a:r>
+          </a:p>
+          <a:p>
+            <a:pPr marL="457200" marR="0" lvl="0" indent="-457200" algn="l" defTabSz="914400" rtl="0" eaLnBrk="0" fontAlgn="base" latinLnBrk="0" hangingPunct="0">
+              <a:lnSpc>
+                <a:spcPct val="100000"/>
+              </a:lnSpc>
+              <a:spcBef>
+                <a:spcPct val="0"/>
+              </a:spcBef>
+              <a:spcAft>
+                <a:spcPct val="0"/>
+              </a:spcAft>
+              <a:buClrTx/>
+              <a:buSzTx/>
+              <a:buFont typeface="+mj-lt"/>
+              <a:buAutoNum type="arabicPeriod"/>
+              <a:tabLst/>
+            </a:pPr>
+            <a:endParaRPr kumimoji="0" lang="en-US" altLang="en-US" sz="2400" b="0" i="0" u="none" strike="noStrike" cap="none" normalizeH="0" baseline="0" dirty="0">
+              <a:ln>
+                <a:noFill/>
+              </a:ln>
+              <a:solidFill>
+                <a:schemeClr val="tx1"/>
+              </a:solidFill>
+              <a:effectLst/>
+              <a:latin typeface="Arial" panose="020B0604020202020204" pitchFamily="34" charset="0"/>
+            </a:endParaRPr>
+          </a:p>
+          <a:p>
+            <a:pPr marL="0" marR="0" lvl="0" indent="0" algn="l" defTabSz="914400" rtl="0" eaLnBrk="0" fontAlgn="base" latinLnBrk="0" hangingPunct="0">
+              <a:lnSpc>
+                <a:spcPct val="100000"/>
+              </a:lnSpc>
+              <a:spcBef>
+                <a:spcPct val="0"/>
+              </a:spcBef>
+              <a:spcAft>
+                <a:spcPct val="0"/>
+              </a:spcAft>
+              <a:buClrTx/>
+              <a:buSzTx/>
+              <a:tabLst/>
+            </a:pPr>
             <a:r>
               <a:rPr kumimoji="0" lang="en-US" altLang="en-US" sz="2400" b="0" i="0" u="none" strike="noStrike" cap="none" normalizeH="0" baseline="0" dirty="0">
                 <a:ln>
@@ -4841,13 +4958,721 @@
                   <a:schemeClr val="tx1"/>
                 </a:solidFill>
                 <a:effectLst/>
-                <a:latin typeface="Arial Nova" panose="020B0504020202020204" pitchFamily="34" charset="0"/>
-              </a:rPr>
-              <a:t> The square root of the average squared error.</a:t>
-            </a:r>
-          </a:p>
-          <a:p>
-            <a:pPr marL="457200" marR="0" lvl="1" indent="0" algn="l" defTabSz="914400" rtl="0" eaLnBrk="0" fontAlgn="base" latinLnBrk="0" hangingPunct="0">
+                <a:latin typeface="Arial" panose="020B0604020202020204" pitchFamily="34" charset="0"/>
+              </a:rPr>
+              <a:t>These metrics help us understand </a:t>
+            </a:r>
+            <a:r>
+              <a:rPr kumimoji="0" lang="en-US" altLang="en-US" sz="2400" b="1" i="0" u="none" strike="noStrike" cap="none" normalizeH="0" baseline="0" dirty="0">
+                <a:ln>
+                  <a:noFill/>
+                </a:ln>
+                <a:solidFill>
+                  <a:schemeClr val="tx1"/>
+                </a:solidFill>
+                <a:effectLst/>
+                <a:latin typeface="Arial" panose="020B0604020202020204" pitchFamily="34" charset="0"/>
+              </a:rPr>
+              <a:t>accuracy</a:t>
+            </a:r>
+            <a:r>
+              <a:rPr kumimoji="0" lang="en-US" altLang="en-US" sz="2400" b="0" i="0" u="none" strike="noStrike" cap="none" normalizeH="0" baseline="0" dirty="0">
+                <a:ln>
+                  <a:noFill/>
+                </a:ln>
+                <a:solidFill>
+                  <a:schemeClr val="tx1"/>
+                </a:solidFill>
+                <a:effectLst/>
+                <a:latin typeface="Arial" panose="020B0604020202020204" pitchFamily="34" charset="0"/>
+              </a:rPr>
+              <a:t> and </a:t>
+            </a:r>
+            <a:r>
+              <a:rPr kumimoji="0" lang="en-US" altLang="en-US" sz="2400" b="1" i="0" u="none" strike="noStrike" cap="none" normalizeH="0" baseline="0" dirty="0">
+                <a:ln>
+                  <a:noFill/>
+                </a:ln>
+                <a:solidFill>
+                  <a:schemeClr val="tx1"/>
+                </a:solidFill>
+                <a:effectLst/>
+                <a:latin typeface="Arial" panose="020B0604020202020204" pitchFamily="34" charset="0"/>
+              </a:rPr>
+              <a:t>error magnitude</a:t>
+            </a:r>
+            <a:r>
+              <a:rPr kumimoji="0" lang="en-US" altLang="en-US" sz="2400" b="0" i="0" u="none" strike="noStrike" cap="none" normalizeH="0" baseline="0" dirty="0">
+                <a:ln>
+                  <a:noFill/>
+                </a:ln>
+                <a:solidFill>
+                  <a:schemeClr val="tx1"/>
+                </a:solidFill>
+                <a:effectLst/>
+                <a:latin typeface="Arial" panose="020B0604020202020204" pitchFamily="34" charset="0"/>
+              </a:rPr>
+              <a:t> of predictions.</a:t>
+            </a:r>
+          </a:p>
+        </p:txBody>
+      </p:sp>
+    </p:spTree>
+    <p:extLst>
+      <p:ext uri="{BB962C8B-B14F-4D97-AF65-F5344CB8AC3E}">
+        <p14:creationId xmlns:p14="http://schemas.microsoft.com/office/powerpoint/2010/main" val="2025344923"/>
+      </p:ext>
+    </p:extLst>
+  </p:cSld>
+  <p:clrMapOvr>
+    <a:masterClrMapping/>
+  </p:clrMapOvr>
+</p:sld>
+</file>
+
+<file path=ppt/slides/slide5.xml><?xml version="1.0" encoding="utf-8"?>
+<p:sld xmlns:a="http://schemas.openxmlformats.org/drawingml/2006/main" xmlns:r="http://schemas.openxmlformats.org/officeDocument/2006/relationships" xmlns:p="http://schemas.openxmlformats.org/presentationml/2006/main">
+  <p:cSld>
+    <p:spTree>
+      <p:nvGrpSpPr>
+        <p:cNvPr id="1" name=""/>
+        <p:cNvGrpSpPr/>
+        <p:nvPr/>
+      </p:nvGrpSpPr>
+      <p:grpSpPr>
+        <a:xfrm>
+          <a:off x="0" y="0"/>
+          <a:ext cx="0" cy="0"/>
+          <a:chOff x="0" y="0"/>
+          <a:chExt cx="0" cy="0"/>
+        </a:xfrm>
+      </p:grpSpPr>
+      <p:sp>
+        <p:nvSpPr>
+          <p:cNvPr id="3" name="TextBox 2">
+            <a:extLst>
+              <a:ext uri="{FF2B5EF4-FFF2-40B4-BE49-F238E27FC236}">
+                <a16:creationId xmlns:a16="http://schemas.microsoft.com/office/drawing/2014/main" id="{A03BE903-7CF1-E28E-CEF8-6C0C336D7550}"/>
+              </a:ext>
+            </a:extLst>
+          </p:cNvPr>
+          <p:cNvSpPr txBox="1"/>
+          <p:nvPr/>
+        </p:nvSpPr>
+        <p:spPr>
+          <a:xfrm>
+            <a:off x="3048000" y="232429"/>
+            <a:ext cx="6096000" cy="584775"/>
+          </a:xfrm>
+          <a:prstGeom prst="rect">
+            <a:avLst/>
+          </a:prstGeom>
+          <a:noFill/>
+        </p:spPr>
+        <p:txBody>
+          <a:bodyPr wrap="square">
+            <a:spAutoFit/>
+          </a:bodyPr>
+          <a:lstStyle/>
+          <a:p>
+            <a:r>
+              <a:rPr lang="en-US" sz="3200" dirty="0">
+                <a:latin typeface="Arial Black" panose="020B0A04020102020204" pitchFamily="34" charset="0"/>
+              </a:rPr>
+              <a:t>Understanding R² Score</a:t>
+            </a:r>
+          </a:p>
+        </p:txBody>
+      </p:sp>
+      <p:sp>
+        <p:nvSpPr>
+          <p:cNvPr id="5" name="TextBox 4">
+            <a:extLst>
+              <a:ext uri="{FF2B5EF4-FFF2-40B4-BE49-F238E27FC236}">
+                <a16:creationId xmlns:a16="http://schemas.microsoft.com/office/drawing/2014/main" id="{F8D51BC0-4FD3-66F0-F2AF-783E0B26F6A1}"/>
+              </a:ext>
+            </a:extLst>
+          </p:cNvPr>
+          <p:cNvSpPr txBox="1"/>
+          <p:nvPr/>
+        </p:nvSpPr>
+        <p:spPr>
+          <a:xfrm>
+            <a:off x="770021" y="1026696"/>
+            <a:ext cx="9240253" cy="4893647"/>
+          </a:xfrm>
+          <a:prstGeom prst="rect">
+            <a:avLst/>
+          </a:prstGeom>
+          <a:noFill/>
+        </p:spPr>
+        <p:txBody>
+          <a:bodyPr wrap="square">
+            <a:spAutoFit/>
+          </a:bodyPr>
+          <a:lstStyle/>
+          <a:p>
+            <a:r>
+              <a:rPr lang="en-US" sz="2400" b="1" dirty="0">
+                <a:latin typeface="Arial" panose="020B0604020202020204" pitchFamily="34" charset="0"/>
+                <a:cs typeface="Arial" panose="020B0604020202020204" pitchFamily="34" charset="0"/>
+              </a:rPr>
+              <a:t>R²</a:t>
+            </a:r>
+            <a:r>
+              <a:rPr lang="en-US" sz="2400" dirty="0">
+                <a:latin typeface="Arial" panose="020B0604020202020204" pitchFamily="34" charset="0"/>
+                <a:cs typeface="Arial" panose="020B0604020202020204" pitchFamily="34" charset="0"/>
+              </a:rPr>
+              <a:t> measures how well the model explains the </a:t>
+            </a:r>
+            <a:r>
+              <a:rPr lang="en-US" sz="2400" b="1" dirty="0">
+                <a:latin typeface="Arial" panose="020B0604020202020204" pitchFamily="34" charset="0"/>
+                <a:cs typeface="Arial" panose="020B0604020202020204" pitchFamily="34" charset="0"/>
+              </a:rPr>
+              <a:t>variance in the target variable</a:t>
+            </a:r>
+            <a:r>
+              <a:rPr lang="en-US" sz="2400" dirty="0">
+                <a:latin typeface="Arial" panose="020B0604020202020204" pitchFamily="34" charset="0"/>
+                <a:cs typeface="Arial" panose="020B0604020202020204" pitchFamily="34" charset="0"/>
+              </a:rPr>
+              <a:t>.</a:t>
+            </a:r>
+          </a:p>
+          <a:p>
+            <a:r>
+              <a:rPr lang="en-US" sz="2400" b="1" dirty="0">
+                <a:latin typeface="Arial" panose="020B0604020202020204" pitchFamily="34" charset="0"/>
+                <a:cs typeface="Arial" panose="020B0604020202020204" pitchFamily="34" charset="0"/>
+              </a:rPr>
+              <a:t>R²</a:t>
+            </a:r>
+            <a:r>
+              <a:rPr lang="en-US" sz="2400" dirty="0">
+                <a:latin typeface="Arial" panose="020B0604020202020204" pitchFamily="34" charset="0"/>
+                <a:cs typeface="Arial" panose="020B0604020202020204" pitchFamily="34" charset="0"/>
+              </a:rPr>
+              <a:t> ranges from </a:t>
+            </a:r>
+            <a:r>
+              <a:rPr lang="en-US" sz="2400" b="1" dirty="0">
+                <a:latin typeface="Arial" panose="020B0604020202020204" pitchFamily="34" charset="0"/>
+                <a:cs typeface="Arial" panose="020B0604020202020204" pitchFamily="34" charset="0"/>
+              </a:rPr>
+              <a:t>0 to 1</a:t>
+            </a:r>
+            <a:r>
+              <a:rPr lang="en-US" sz="2400" dirty="0">
+                <a:latin typeface="Arial" panose="020B0604020202020204" pitchFamily="34" charset="0"/>
+                <a:cs typeface="Arial" panose="020B0604020202020204" pitchFamily="34" charset="0"/>
+              </a:rPr>
+              <a:t> (or can be negative in poor models).</a:t>
+            </a:r>
+          </a:p>
+          <a:p>
+            <a:endParaRPr lang="en-US" sz="2400" dirty="0">
+              <a:latin typeface="Arial" panose="020B0604020202020204" pitchFamily="34" charset="0"/>
+              <a:cs typeface="Arial" panose="020B0604020202020204" pitchFamily="34" charset="0"/>
+            </a:endParaRPr>
+          </a:p>
+          <a:p>
+            <a:pPr>
+              <a:buFont typeface="Arial" panose="020B0604020202020204" pitchFamily="34" charset="0"/>
+              <a:buChar char="•"/>
+            </a:pPr>
+            <a:r>
+              <a:rPr lang="en-US" sz="2400" dirty="0">
+                <a:latin typeface="Arial" panose="020B0604020202020204" pitchFamily="34" charset="0"/>
+                <a:cs typeface="Arial" panose="020B0604020202020204" pitchFamily="34" charset="0"/>
+              </a:rPr>
+              <a:t>Interpretation:</a:t>
+            </a:r>
+          </a:p>
+          <a:p>
+            <a:pPr marL="742950" lvl="1" indent="-285750">
+              <a:buFont typeface="Arial" panose="020B0604020202020204" pitchFamily="34" charset="0"/>
+              <a:buChar char="•"/>
+            </a:pPr>
+            <a:r>
+              <a:rPr lang="en-US" sz="2400" b="1" dirty="0">
+                <a:latin typeface="Arial" panose="020B0604020202020204" pitchFamily="34" charset="0"/>
+                <a:cs typeface="Arial" panose="020B0604020202020204" pitchFamily="34" charset="0"/>
+              </a:rPr>
+              <a:t>R² = 0</a:t>
+            </a:r>
+            <a:r>
+              <a:rPr lang="en-US" sz="2400" dirty="0">
+                <a:latin typeface="Arial" panose="020B0604020202020204" pitchFamily="34" charset="0"/>
+                <a:cs typeface="Arial" panose="020B0604020202020204" pitchFamily="34" charset="0"/>
+              </a:rPr>
+              <a:t> → model explains nothing</a:t>
+            </a:r>
+          </a:p>
+          <a:p>
+            <a:pPr marL="742950" lvl="1" indent="-285750">
+              <a:buFont typeface="Arial" panose="020B0604020202020204" pitchFamily="34" charset="0"/>
+              <a:buChar char="•"/>
+            </a:pPr>
+            <a:r>
+              <a:rPr lang="en-US" sz="2400" b="1" dirty="0">
+                <a:latin typeface="Arial" panose="020B0604020202020204" pitchFamily="34" charset="0"/>
+                <a:cs typeface="Arial" panose="020B0604020202020204" pitchFamily="34" charset="0"/>
+              </a:rPr>
+              <a:t>R² = 1</a:t>
+            </a:r>
+            <a:r>
+              <a:rPr lang="en-US" sz="2400" dirty="0">
+                <a:latin typeface="Arial" panose="020B0604020202020204" pitchFamily="34" charset="0"/>
+                <a:cs typeface="Arial" panose="020B0604020202020204" pitchFamily="34" charset="0"/>
+              </a:rPr>
+              <a:t> → perfect prediction</a:t>
+            </a:r>
+          </a:p>
+          <a:p>
+            <a:pPr>
+              <a:buFont typeface="Arial" panose="020B0604020202020204" pitchFamily="34" charset="0"/>
+              <a:buChar char="•"/>
+            </a:pPr>
+            <a:r>
+              <a:rPr lang="en-US" sz="2400" dirty="0">
+                <a:latin typeface="Arial" panose="020B0604020202020204" pitchFamily="34" charset="0"/>
+                <a:cs typeface="Arial" panose="020B0604020202020204" pitchFamily="34" charset="0"/>
+              </a:rPr>
+              <a:t>In our model:</a:t>
+            </a:r>
+          </a:p>
+          <a:p>
+            <a:pPr marL="742950" lvl="1" indent="-285750">
+              <a:buFont typeface="Arial" panose="020B0604020202020204" pitchFamily="34" charset="0"/>
+              <a:buChar char="•"/>
+            </a:pPr>
+            <a:r>
+              <a:rPr lang="en-US" sz="2400" dirty="0">
+                <a:latin typeface="Arial" panose="020B0604020202020204" pitchFamily="34" charset="0"/>
+                <a:cs typeface="Arial" panose="020B0604020202020204" pitchFamily="34" charset="0"/>
+              </a:rPr>
+              <a:t>Validation R² ≈ </a:t>
+            </a:r>
+            <a:r>
+              <a:rPr lang="en-US" sz="2400" b="1" dirty="0">
+                <a:latin typeface="Arial" panose="020B0604020202020204" pitchFamily="34" charset="0"/>
+                <a:cs typeface="Arial" panose="020B0604020202020204" pitchFamily="34" charset="0"/>
+              </a:rPr>
+              <a:t>0.83</a:t>
+            </a:r>
+            <a:endParaRPr lang="en-US" sz="2400" dirty="0">
+              <a:latin typeface="Arial" panose="020B0604020202020204" pitchFamily="34" charset="0"/>
+              <a:cs typeface="Arial" panose="020B0604020202020204" pitchFamily="34" charset="0"/>
+            </a:endParaRPr>
+          </a:p>
+          <a:p>
+            <a:pPr marL="742950" lvl="1" indent="-285750">
+              <a:buFont typeface="Arial" panose="020B0604020202020204" pitchFamily="34" charset="0"/>
+              <a:buChar char="•"/>
+            </a:pPr>
+            <a:r>
+              <a:rPr lang="en-US" sz="2400" dirty="0">
+                <a:latin typeface="Arial" panose="020B0604020202020204" pitchFamily="34" charset="0"/>
+                <a:cs typeface="Arial" panose="020B0604020202020204" pitchFamily="34" charset="0"/>
+              </a:rPr>
+              <a:t>Test R² ≈ </a:t>
+            </a:r>
+            <a:r>
+              <a:rPr lang="en-US" sz="2400" b="1" dirty="0">
+                <a:latin typeface="Arial" panose="020B0604020202020204" pitchFamily="34" charset="0"/>
+                <a:cs typeface="Arial" panose="020B0604020202020204" pitchFamily="34" charset="0"/>
+              </a:rPr>
+              <a:t>0.77</a:t>
+            </a:r>
+          </a:p>
+          <a:p>
+            <a:pPr marL="742950" lvl="1" indent="-285750">
+              <a:buFont typeface="Arial" panose="020B0604020202020204" pitchFamily="34" charset="0"/>
+              <a:buChar char="•"/>
+            </a:pPr>
+            <a:endParaRPr lang="en-US" sz="2400" dirty="0">
+              <a:latin typeface="Arial" panose="020B0604020202020204" pitchFamily="34" charset="0"/>
+              <a:cs typeface="Arial" panose="020B0604020202020204" pitchFamily="34" charset="0"/>
+            </a:endParaRPr>
+          </a:p>
+          <a:p>
+            <a:pPr>
+              <a:buNone/>
+            </a:pPr>
+            <a:r>
+              <a:rPr lang="en-US" sz="2400" dirty="0">
+                <a:latin typeface="Arial" panose="020B0604020202020204" pitchFamily="34" charset="0"/>
+                <a:cs typeface="Arial" panose="020B0604020202020204" pitchFamily="34" charset="0"/>
+              </a:rPr>
+              <a:t>This means the model explains </a:t>
+            </a:r>
+            <a:r>
+              <a:rPr lang="en-US" sz="2400" b="1" dirty="0">
+                <a:latin typeface="Arial" panose="020B0604020202020204" pitchFamily="34" charset="0"/>
+                <a:cs typeface="Arial" panose="020B0604020202020204" pitchFamily="34" charset="0"/>
+              </a:rPr>
+              <a:t>77–83% of house price variation</a:t>
+            </a:r>
+            <a:r>
+              <a:rPr lang="en-US" sz="2400" dirty="0">
+                <a:latin typeface="Arial" panose="020B0604020202020204" pitchFamily="34" charset="0"/>
+                <a:cs typeface="Arial" panose="020B0604020202020204" pitchFamily="34" charset="0"/>
+              </a:rPr>
+              <a:t>, which is strong for Linear Regression.</a:t>
+            </a:r>
+          </a:p>
+        </p:txBody>
+      </p:sp>
+    </p:spTree>
+    <p:extLst>
+      <p:ext uri="{BB962C8B-B14F-4D97-AF65-F5344CB8AC3E}">
+        <p14:creationId xmlns:p14="http://schemas.microsoft.com/office/powerpoint/2010/main" val="1552580315"/>
+      </p:ext>
+    </p:extLst>
+  </p:cSld>
+  <p:clrMapOvr>
+    <a:masterClrMapping/>
+  </p:clrMapOvr>
+</p:sld>
+</file>
+
+<file path=ppt/slides/slide6.xml><?xml version="1.0" encoding="utf-8"?>
+<p:sld xmlns:a="http://schemas.openxmlformats.org/drawingml/2006/main" xmlns:r="http://schemas.openxmlformats.org/officeDocument/2006/relationships" xmlns:p="http://schemas.openxmlformats.org/presentationml/2006/main">
+  <p:cSld>
+    <p:spTree>
+      <p:nvGrpSpPr>
+        <p:cNvPr id="1" name=""/>
+        <p:cNvGrpSpPr/>
+        <p:nvPr/>
+      </p:nvGrpSpPr>
+      <p:grpSpPr>
+        <a:xfrm>
+          <a:off x="0" y="0"/>
+          <a:ext cx="0" cy="0"/>
+          <a:chOff x="0" y="0"/>
+          <a:chExt cx="0" cy="0"/>
+        </a:xfrm>
+      </p:grpSpPr>
+      <p:sp>
+        <p:nvSpPr>
+          <p:cNvPr id="3" name="TextBox 2">
+            <a:extLst>
+              <a:ext uri="{FF2B5EF4-FFF2-40B4-BE49-F238E27FC236}">
+                <a16:creationId xmlns:a16="http://schemas.microsoft.com/office/drawing/2014/main" id="{E3E24ADF-EEAE-A4CC-4776-99A59FE7FE1A}"/>
+              </a:ext>
+            </a:extLst>
+          </p:cNvPr>
+          <p:cNvSpPr txBox="1"/>
+          <p:nvPr/>
+        </p:nvSpPr>
+        <p:spPr>
+          <a:xfrm>
+            <a:off x="882315" y="280555"/>
+            <a:ext cx="10427369" cy="1077218"/>
+          </a:xfrm>
+          <a:prstGeom prst="rect">
+            <a:avLst/>
+          </a:prstGeom>
+          <a:noFill/>
+        </p:spPr>
+        <p:txBody>
+          <a:bodyPr wrap="square">
+            <a:spAutoFit/>
+          </a:bodyPr>
+          <a:lstStyle/>
+          <a:p>
+            <a:r>
+              <a:rPr lang="en-US" sz="3200" dirty="0">
+                <a:latin typeface="Arial Black" panose="020B0A04020102020204" pitchFamily="34" charset="0"/>
+              </a:rPr>
+              <a:t>Understanding RMSE </a:t>
+            </a:r>
+            <a:r>
+              <a:rPr lang="en-US" altLang="en-US" sz="3200" dirty="0">
+                <a:latin typeface="Arial" panose="020B0604020202020204" pitchFamily="34" charset="0"/>
+              </a:rPr>
+              <a:t>(Root Mean Squared Error</a:t>
+            </a:r>
+            <a:r>
+              <a:rPr lang="en-US" altLang="en-US" sz="3200" b="1" dirty="0">
+                <a:latin typeface="Arial" panose="020B0604020202020204" pitchFamily="34" charset="0"/>
+              </a:rPr>
+              <a:t>)</a:t>
+            </a:r>
+          </a:p>
+          <a:p>
+            <a:endParaRPr lang="en-US" sz="3200" dirty="0">
+              <a:latin typeface="Arial Black" panose="020B0A04020102020204" pitchFamily="34" charset="0"/>
+            </a:endParaRPr>
+          </a:p>
+        </p:txBody>
+      </p:sp>
+      <p:sp>
+        <p:nvSpPr>
+          <p:cNvPr id="5" name="TextBox 4">
+            <a:extLst>
+              <a:ext uri="{FF2B5EF4-FFF2-40B4-BE49-F238E27FC236}">
+                <a16:creationId xmlns:a16="http://schemas.microsoft.com/office/drawing/2014/main" id="{9E37428B-C12C-36EE-3393-2FDDDD0BE13B}"/>
+              </a:ext>
+            </a:extLst>
+          </p:cNvPr>
+          <p:cNvSpPr txBox="1"/>
+          <p:nvPr/>
+        </p:nvSpPr>
+        <p:spPr>
+          <a:xfrm>
+            <a:off x="882315" y="1351508"/>
+            <a:ext cx="7379369" cy="4154984"/>
+          </a:xfrm>
+          <a:prstGeom prst="rect">
+            <a:avLst/>
+          </a:prstGeom>
+          <a:noFill/>
+        </p:spPr>
+        <p:txBody>
+          <a:bodyPr wrap="square">
+            <a:spAutoFit/>
+          </a:bodyPr>
+          <a:lstStyle/>
+          <a:p>
+            <a:r>
+              <a:rPr lang="en-US" sz="2400" b="1" dirty="0"/>
+              <a:t>RMSE</a:t>
+            </a:r>
+            <a:r>
+              <a:rPr lang="en-US" sz="2400" dirty="0"/>
+              <a:t> measures the </a:t>
+            </a:r>
+            <a:r>
+              <a:rPr lang="en-US" sz="2400" b="1" dirty="0"/>
+              <a:t>average prediction error</a:t>
+            </a:r>
+            <a:r>
+              <a:rPr lang="en-US" sz="2400" dirty="0"/>
+              <a:t> in the </a:t>
+            </a:r>
+            <a:r>
+              <a:rPr lang="en-US" sz="2400" b="1" dirty="0"/>
+              <a:t>same unit as the target variable (price)</a:t>
+            </a:r>
+            <a:r>
+              <a:rPr lang="en-US" sz="2400" dirty="0"/>
+              <a:t>.</a:t>
+            </a:r>
+          </a:p>
+          <a:p>
+            <a:endParaRPr lang="en-US" sz="2400" dirty="0"/>
+          </a:p>
+          <a:p>
+            <a:pPr>
+              <a:buFont typeface="Arial" panose="020B0604020202020204" pitchFamily="34" charset="0"/>
+              <a:buChar char="•"/>
+            </a:pPr>
+            <a:r>
+              <a:rPr lang="en-US" sz="2400" dirty="0"/>
+              <a:t> It penalizes larger errors more heavily due to squaring.</a:t>
+            </a:r>
+          </a:p>
+          <a:p>
+            <a:pPr>
+              <a:buFont typeface="Arial" panose="020B0604020202020204" pitchFamily="34" charset="0"/>
+              <a:buChar char="•"/>
+            </a:pPr>
+            <a:r>
+              <a:rPr lang="en-US" sz="2400" dirty="0"/>
+              <a:t> Our model results:</a:t>
+            </a:r>
+          </a:p>
+          <a:p>
+            <a:pPr marL="742950" lvl="1" indent="-285750">
+              <a:buFont typeface="Arial" panose="020B0604020202020204" pitchFamily="34" charset="0"/>
+              <a:buChar char="•"/>
+            </a:pPr>
+            <a:r>
+              <a:rPr lang="en-US" sz="2400" dirty="0"/>
+              <a:t>Validation RMSE ≈ </a:t>
+            </a:r>
+            <a:r>
+              <a:rPr lang="en-US" sz="2400" b="1" dirty="0"/>
+              <a:t>33,000</a:t>
+            </a:r>
+            <a:endParaRPr lang="en-US" sz="2400" dirty="0"/>
+          </a:p>
+          <a:p>
+            <a:pPr marL="742950" lvl="1" indent="-285750">
+              <a:buFont typeface="Arial" panose="020B0604020202020204" pitchFamily="34" charset="0"/>
+              <a:buChar char="•"/>
+            </a:pPr>
+            <a:r>
+              <a:rPr lang="en-US" sz="2400" dirty="0"/>
+              <a:t>Test RMSE ≈ </a:t>
+            </a:r>
+            <a:r>
+              <a:rPr lang="en-US" sz="2400" b="1" dirty="0"/>
+              <a:t>44,000</a:t>
+            </a:r>
+          </a:p>
+          <a:p>
+            <a:pPr marL="742950" lvl="1" indent="-285750">
+              <a:buFont typeface="Arial" panose="020B0604020202020204" pitchFamily="34" charset="0"/>
+              <a:buChar char="•"/>
+            </a:pPr>
+            <a:endParaRPr lang="en-US" sz="2400" dirty="0"/>
+          </a:p>
+          <a:p>
+            <a:pPr>
+              <a:buNone/>
+            </a:pPr>
+            <a:r>
+              <a:rPr lang="en-US" sz="2400" dirty="0"/>
+              <a:t>This means predictions are off by about </a:t>
+            </a:r>
+            <a:r>
+              <a:rPr lang="en-US" sz="2400" b="1" dirty="0"/>
+              <a:t>$33k–$44k on average</a:t>
+            </a:r>
+            <a:r>
+              <a:rPr lang="en-US" sz="2400" dirty="0"/>
+              <a:t>, which is acceptable for real estate pricing.</a:t>
+            </a:r>
+          </a:p>
+        </p:txBody>
+      </p:sp>
+    </p:spTree>
+    <p:extLst>
+      <p:ext uri="{BB962C8B-B14F-4D97-AF65-F5344CB8AC3E}">
+        <p14:creationId xmlns:p14="http://schemas.microsoft.com/office/powerpoint/2010/main" val="617838883"/>
+      </p:ext>
+    </p:extLst>
+  </p:cSld>
+  <p:clrMapOvr>
+    <a:masterClrMapping/>
+  </p:clrMapOvr>
+</p:sld>
+</file>
+
+<file path=ppt/slides/slide7.xml><?xml version="1.0" encoding="utf-8"?>
+<p:sld xmlns:a="http://schemas.openxmlformats.org/drawingml/2006/main" xmlns:r="http://schemas.openxmlformats.org/officeDocument/2006/relationships" xmlns:p="http://schemas.openxmlformats.org/presentationml/2006/main">
+  <p:cSld>
+    <p:spTree>
+      <p:nvGrpSpPr>
+        <p:cNvPr id="1" name=""/>
+        <p:cNvGrpSpPr/>
+        <p:nvPr/>
+      </p:nvGrpSpPr>
+      <p:grpSpPr>
+        <a:xfrm>
+          <a:off x="0" y="0"/>
+          <a:ext cx="0" cy="0"/>
+          <a:chOff x="0" y="0"/>
+          <a:chExt cx="0" cy="0"/>
+        </a:xfrm>
+      </p:grpSpPr>
+      <p:sp>
+        <p:nvSpPr>
+          <p:cNvPr id="3" name="TextBox 2">
+            <a:extLst>
+              <a:ext uri="{FF2B5EF4-FFF2-40B4-BE49-F238E27FC236}">
+                <a16:creationId xmlns:a16="http://schemas.microsoft.com/office/drawing/2014/main" id="{65684509-7420-CED6-61BE-A1DC7B2AA512}"/>
+              </a:ext>
+            </a:extLst>
+          </p:cNvPr>
+          <p:cNvSpPr txBox="1"/>
+          <p:nvPr/>
+        </p:nvSpPr>
+        <p:spPr>
+          <a:xfrm>
+            <a:off x="3481137" y="264512"/>
+            <a:ext cx="6096000" cy="584775"/>
+          </a:xfrm>
+          <a:prstGeom prst="rect">
+            <a:avLst/>
+          </a:prstGeom>
+          <a:noFill/>
+        </p:spPr>
+        <p:txBody>
+          <a:bodyPr wrap="square">
+            <a:spAutoFit/>
+          </a:bodyPr>
+          <a:lstStyle/>
+          <a:p>
+            <a:r>
+              <a:rPr lang="en-US" sz="3200" dirty="0">
+                <a:latin typeface="Arial Black" panose="020B0A04020102020204" pitchFamily="34" charset="0"/>
+              </a:rPr>
+              <a:t>Generalization Check</a:t>
+            </a:r>
+          </a:p>
+        </p:txBody>
+      </p:sp>
+      <p:sp>
+        <p:nvSpPr>
+          <p:cNvPr id="5" name="Rectangle 1">
+            <a:extLst>
+              <a:ext uri="{FF2B5EF4-FFF2-40B4-BE49-F238E27FC236}">
+                <a16:creationId xmlns:a16="http://schemas.microsoft.com/office/drawing/2014/main" id="{C250D3CF-EBB9-AD49-0B37-06F5D2F734DF}"/>
+              </a:ext>
+            </a:extLst>
+          </p:cNvPr>
+          <p:cNvSpPr>
+            <a:spLocks noChangeArrowheads="1"/>
+          </p:cNvSpPr>
+          <p:nvPr/>
+        </p:nvSpPr>
+        <p:spPr bwMode="auto">
+          <a:xfrm>
+            <a:off x="1601585" y="1925704"/>
+            <a:ext cx="9222462" cy="2308324"/>
+          </a:xfrm>
+          <a:prstGeom prst="rect">
+            <a:avLst/>
+          </a:prstGeom>
+          <a:noFill/>
+          <a:ln>
+            <a:noFill/>
+          </a:ln>
+          <a:effectLst/>
+          <a:extLst>
+            <a:ext uri="{909E8E84-426E-40DD-AFC4-6F175D3DCCD1}">
+              <a14:hiddenFill xmlns:a14="http://schemas.microsoft.com/office/drawing/2010/main">
+                <a:solidFill>
+                  <a:schemeClr val="accent1"/>
+                </a:solidFill>
+              </a14:hiddenFill>
+            </a:ext>
+            <a:ext uri="{91240B29-F687-4F45-9708-019B960494DF}">
+              <a14:hiddenLine xmlns:a14="http://schemas.microsoft.com/office/drawing/2010/main" w="9525">
+                <a:solidFill>
+                  <a:schemeClr val="tx1"/>
+                </a:solidFill>
+                <a:miter lim="800000"/>
+                <a:headEnd/>
+                <a:tailEnd/>
+              </a14:hiddenLine>
+            </a:ext>
+            <a:ext uri="{AF507438-7753-43E0-B8FC-AC1667EBCBE1}">
+              <a14:hiddenEffects xmlns:a14="http://schemas.microsoft.com/office/drawing/2010/main">
+                <a:effectLst>
+                  <a:outerShdw dist="35921" dir="2700000" algn="ctr" rotWithShape="0">
+                    <a:schemeClr val="bg2"/>
+                  </a:outerShdw>
+                </a:effectLst>
+              </a14:hiddenEffects>
+            </a:ext>
+          </a:extLst>
+        </p:spPr>
+        <p:txBody>
+          <a:bodyPr vert="horz" wrap="square" lIns="91440" tIns="45720" rIns="91440" bIns="45720" numCol="1" anchor="ctr" anchorCtr="0" compatLnSpc="1">
+            <a:prstTxWarp prst="textNoShape">
+              <a:avLst/>
+            </a:prstTxWarp>
+            <a:spAutoFit/>
+          </a:bodyPr>
+          <a:lstStyle/>
+          <a:p>
+            <a:pPr marL="0" marR="0" lvl="0" indent="0" algn="l" defTabSz="914400" rtl="0" eaLnBrk="0" fontAlgn="base" latinLnBrk="0" hangingPunct="0">
               <a:lnSpc>
                 <a:spcPct val="100000"/>
               </a:lnSpc>
@@ -4864,6 +5689,19 @@
               <a:tabLst/>
             </a:pPr>
             <a:r>
+              <a:rPr kumimoji="0" lang="en-US" altLang="en-US" sz="2400" b="0" i="0" u="none" strike="noStrike" cap="none" normalizeH="0" baseline="0" dirty="0">
+                <a:ln>
+                  <a:noFill/>
+                </a:ln>
+                <a:solidFill>
+                  <a:schemeClr val="tx1"/>
+                </a:solidFill>
+                <a:effectLst/>
+                <a:latin typeface="Arial" panose="020B0604020202020204" pitchFamily="34" charset="0"/>
+              </a:rPr>
+              <a:t> Validation and test scores are </a:t>
+            </a:r>
+            <a:r>
               <a:rPr kumimoji="0" lang="en-US" altLang="en-US" sz="2400" b="1" i="0" u="none" strike="noStrike" cap="none" normalizeH="0" baseline="0" dirty="0">
                 <a:ln>
                   <a:noFill/>
@@ -4872,9 +5710,9 @@
                   <a:schemeClr val="tx1"/>
                 </a:solidFill>
                 <a:effectLst/>
-                <a:latin typeface="Arial Nova" panose="020B0504020202020204" pitchFamily="34" charset="0"/>
-              </a:rPr>
-              <a:t> Unit:</a:t>
+                <a:latin typeface="Arial" panose="020B0604020202020204" pitchFamily="34" charset="0"/>
+              </a:rPr>
+              <a:t>close to each other</a:t>
             </a:r>
             <a:r>
               <a:rPr kumimoji="0" lang="en-US" altLang="en-US" sz="2400" b="0" i="0" u="none" strike="noStrike" cap="none" normalizeH="0" baseline="0" dirty="0">
@@ -4885,13 +5723,13 @@
                   <a:schemeClr val="tx1"/>
                 </a:solidFill>
                 <a:effectLst/>
-                <a:latin typeface="Arial Nova" panose="020B0504020202020204" pitchFamily="34" charset="0"/>
-              </a:rPr>
-              <a:t> Same as the target (Dollars).</a:t>
-            </a:r>
-          </a:p>
-          <a:p>
-            <a:pPr marL="457200" marR="0" lvl="1" indent="0" algn="l" defTabSz="914400" rtl="0" eaLnBrk="0" fontAlgn="base" latinLnBrk="0" hangingPunct="0">
+                <a:latin typeface="Arial" panose="020B0604020202020204" pitchFamily="34" charset="0"/>
+              </a:rPr>
+              <a:t>.</a:t>
+            </a:r>
+          </a:p>
+          <a:p>
+            <a:pPr marL="0" marR="0" lvl="0" indent="0" algn="l" defTabSz="914400" rtl="0" eaLnBrk="0" fontAlgn="base" latinLnBrk="0" hangingPunct="0">
               <a:lnSpc>
                 <a:spcPct val="100000"/>
               </a:lnSpc>
@@ -4908,19 +5746,6 @@
               <a:tabLst/>
             </a:pPr>
             <a:r>
-              <a:rPr kumimoji="0" lang="en-US" altLang="en-US" sz="2400" b="1" i="0" u="none" strike="noStrike" cap="none" normalizeH="0" baseline="0" dirty="0">
-                <a:ln>
-                  <a:noFill/>
-                </a:ln>
-                <a:solidFill>
-                  <a:schemeClr val="tx1"/>
-                </a:solidFill>
-                <a:effectLst/>
-                <a:latin typeface="Arial Nova" panose="020B0504020202020204" pitchFamily="34" charset="0"/>
-              </a:rPr>
-              <a:t> Why it matters:</a:t>
-            </a:r>
-            <a:r>
               <a:rPr kumimoji="0" lang="en-US" altLang="en-US" sz="2400" b="0" i="0" u="none" strike="noStrike" cap="none" normalizeH="0" baseline="0" dirty="0">
                 <a:ln>
                   <a:noFill/>
@@ -4929,9 +5754,9 @@
                   <a:schemeClr val="tx1"/>
                 </a:solidFill>
                 <a:effectLst/>
-                <a:latin typeface="Arial Nova" panose="020B0504020202020204" pitchFamily="34" charset="0"/>
-              </a:rPr>
-              <a:t> It tells us the average magnitude of our error. If RMSE is 30,000, our predictions are, on average, off by $30k.</a:t>
+                <a:latin typeface="Arial" panose="020B0604020202020204" pitchFamily="34" charset="0"/>
+              </a:rPr>
+              <a:t> Small performance drop from validation to test indicates:</a:t>
             </a:r>
           </a:p>
           <a:p>
@@ -4948,6 +5773,537 @@
               <a:buClrTx/>
               <a:buSzTx/>
               <a:buFontTx/>
+              <a:buChar char="•"/>
+              <a:tabLst/>
+            </a:pPr>
+            <a:r>
+              <a:rPr kumimoji="0" lang="en-US" altLang="en-US" sz="2400" b="0" i="0" u="none" strike="noStrike" cap="none" normalizeH="0" baseline="0" dirty="0">
+                <a:ln>
+                  <a:noFill/>
+                </a:ln>
+                <a:solidFill>
+                  <a:schemeClr val="tx1"/>
+                </a:solidFill>
+                <a:effectLst/>
+                <a:latin typeface="Arial" panose="020B0604020202020204" pitchFamily="34" charset="0"/>
+              </a:rPr>
+              <a:t> Model is </a:t>
+            </a:r>
+            <a:r>
+              <a:rPr kumimoji="0" lang="en-US" altLang="en-US" sz="2400" b="1" i="0" u="none" strike="noStrike" cap="none" normalizeH="0" baseline="0" dirty="0">
+                <a:ln>
+                  <a:noFill/>
+                </a:ln>
+                <a:solidFill>
+                  <a:schemeClr val="tx1"/>
+                </a:solidFill>
+                <a:effectLst/>
+                <a:latin typeface="Arial" panose="020B0604020202020204" pitchFamily="34" charset="0"/>
+              </a:rPr>
+              <a:t>not overfitting</a:t>
+            </a:r>
+            <a:endParaRPr kumimoji="0" lang="en-US" altLang="en-US" sz="2400" b="0" i="0" u="none" strike="noStrike" cap="none" normalizeH="0" baseline="0" dirty="0">
+              <a:ln>
+                <a:noFill/>
+              </a:ln>
+              <a:solidFill>
+                <a:schemeClr val="tx1"/>
+              </a:solidFill>
+              <a:effectLst/>
+              <a:latin typeface="Arial" panose="020B0604020202020204" pitchFamily="34" charset="0"/>
+            </a:endParaRPr>
+          </a:p>
+          <a:p>
+            <a:pPr marL="0" marR="0" lvl="0" indent="0" algn="l" defTabSz="914400" rtl="0" eaLnBrk="0" fontAlgn="base" latinLnBrk="0" hangingPunct="0">
+              <a:lnSpc>
+                <a:spcPct val="100000"/>
+              </a:lnSpc>
+              <a:spcBef>
+                <a:spcPct val="0"/>
+              </a:spcBef>
+              <a:spcAft>
+                <a:spcPct val="0"/>
+              </a:spcAft>
+              <a:buClrTx/>
+              <a:buSzTx/>
+              <a:buFontTx/>
+              <a:buChar char="•"/>
+              <a:tabLst/>
+            </a:pPr>
+            <a:r>
+              <a:rPr kumimoji="0" lang="en-US" altLang="en-US" sz="2400" b="0" i="0" u="none" strike="noStrike" cap="none" normalizeH="0" baseline="0" dirty="0">
+                <a:ln>
+                  <a:noFill/>
+                </a:ln>
+                <a:solidFill>
+                  <a:schemeClr val="tx1"/>
+                </a:solidFill>
+                <a:effectLst/>
+                <a:latin typeface="Arial" panose="020B0604020202020204" pitchFamily="34" charset="0"/>
+              </a:rPr>
+              <a:t> Model generalizes well to unseen data</a:t>
+            </a:r>
+          </a:p>
+          <a:p>
+            <a:pPr marL="0" marR="0" lvl="0" indent="0" algn="l" defTabSz="914400" rtl="0" eaLnBrk="0" fontAlgn="base" latinLnBrk="0" hangingPunct="0">
+              <a:lnSpc>
+                <a:spcPct val="100000"/>
+              </a:lnSpc>
+              <a:spcBef>
+                <a:spcPct val="0"/>
+              </a:spcBef>
+              <a:spcAft>
+                <a:spcPct val="0"/>
+              </a:spcAft>
+              <a:buClrTx/>
+              <a:buSzTx/>
+              <a:buFontTx/>
+              <a:buChar char="•"/>
+              <a:tabLst/>
+            </a:pPr>
+            <a:r>
+              <a:rPr kumimoji="0" lang="en-US" altLang="en-US" sz="2400" b="0" i="0" u="none" strike="noStrike" cap="none" normalizeH="0" baseline="0" dirty="0">
+                <a:ln>
+                  <a:noFill/>
+                </a:ln>
+                <a:solidFill>
+                  <a:schemeClr val="tx1"/>
+                </a:solidFill>
+                <a:effectLst/>
+                <a:latin typeface="Arial" panose="020B0604020202020204" pitchFamily="34" charset="0"/>
+              </a:rPr>
+              <a:t> Large drops would indicate overfitting or data leakage, which is </a:t>
+            </a:r>
+            <a:r>
+              <a:rPr kumimoji="0" lang="en-US" altLang="en-US" sz="2400" b="1" i="0" u="none" strike="noStrike" cap="none" normalizeH="0" baseline="0" dirty="0">
+                <a:ln>
+                  <a:noFill/>
+                </a:ln>
+                <a:solidFill>
+                  <a:schemeClr val="tx1"/>
+                </a:solidFill>
+                <a:effectLst/>
+                <a:latin typeface="Arial" panose="020B0604020202020204" pitchFamily="34" charset="0"/>
+              </a:rPr>
+              <a:t>not observed here</a:t>
+            </a:r>
+            <a:r>
+              <a:rPr kumimoji="0" lang="en-US" altLang="en-US" sz="2400" b="0" i="0" u="none" strike="noStrike" cap="none" normalizeH="0" baseline="0" dirty="0">
+                <a:ln>
+                  <a:noFill/>
+                </a:ln>
+                <a:solidFill>
+                  <a:schemeClr val="tx1"/>
+                </a:solidFill>
+                <a:effectLst/>
+                <a:latin typeface="Arial" panose="020B0604020202020204" pitchFamily="34" charset="0"/>
+              </a:rPr>
+              <a:t>.</a:t>
+            </a:r>
+          </a:p>
+        </p:txBody>
+      </p:sp>
+    </p:spTree>
+    <p:extLst>
+      <p:ext uri="{BB962C8B-B14F-4D97-AF65-F5344CB8AC3E}">
+        <p14:creationId xmlns:p14="http://schemas.microsoft.com/office/powerpoint/2010/main" val="759681921"/>
+      </p:ext>
+    </p:extLst>
+  </p:cSld>
+  <p:clrMapOvr>
+    <a:masterClrMapping/>
+  </p:clrMapOvr>
+</p:sld>
+</file>
+
+<file path=ppt/slides/slide8.xml><?xml version="1.0" encoding="utf-8"?>
+<p:sld xmlns:a="http://schemas.openxmlformats.org/drawingml/2006/main" xmlns:r="http://schemas.openxmlformats.org/officeDocument/2006/relationships" xmlns:p="http://schemas.openxmlformats.org/presentationml/2006/main">
+  <p:cSld>
+    <p:spTree>
+      <p:nvGrpSpPr>
+        <p:cNvPr id="1" name=""/>
+        <p:cNvGrpSpPr/>
+        <p:nvPr/>
+      </p:nvGrpSpPr>
+      <p:grpSpPr>
+        <a:xfrm>
+          <a:off x="0" y="0"/>
+          <a:ext cx="0" cy="0"/>
+          <a:chOff x="0" y="0"/>
+          <a:chExt cx="0" cy="0"/>
+        </a:xfrm>
+      </p:grpSpPr>
+      <p:sp>
+        <p:nvSpPr>
+          <p:cNvPr id="3" name="TextBox 2">
+            <a:extLst>
+              <a:ext uri="{FF2B5EF4-FFF2-40B4-BE49-F238E27FC236}">
+                <a16:creationId xmlns:a16="http://schemas.microsoft.com/office/drawing/2014/main" id="{894179FA-06B7-A9BA-745C-6472E3EDEB56}"/>
+              </a:ext>
+            </a:extLst>
+          </p:cNvPr>
+          <p:cNvSpPr txBox="1"/>
+          <p:nvPr/>
+        </p:nvSpPr>
+        <p:spPr>
+          <a:xfrm>
+            <a:off x="3048000" y="248470"/>
+            <a:ext cx="6096000" cy="584775"/>
+          </a:xfrm>
+          <a:prstGeom prst="rect">
+            <a:avLst/>
+          </a:prstGeom>
+          <a:noFill/>
+        </p:spPr>
+        <p:txBody>
+          <a:bodyPr wrap="square">
+            <a:spAutoFit/>
+          </a:bodyPr>
+          <a:lstStyle/>
+          <a:p>
+            <a:r>
+              <a:rPr lang="en-US" sz="3200" dirty="0">
+                <a:latin typeface="Arial Black" panose="020B0A04020102020204" pitchFamily="34" charset="0"/>
+              </a:rPr>
+              <a:t>Performance Assessment</a:t>
+            </a:r>
+          </a:p>
+        </p:txBody>
+      </p:sp>
+      <p:sp>
+        <p:nvSpPr>
+          <p:cNvPr id="4" name="Rectangle 1">
+            <a:extLst>
+              <a:ext uri="{FF2B5EF4-FFF2-40B4-BE49-F238E27FC236}">
+                <a16:creationId xmlns:a16="http://schemas.microsoft.com/office/drawing/2014/main" id="{5C4A5CD1-76C5-0B62-F714-DA2A20BEB212}"/>
+              </a:ext>
+            </a:extLst>
+          </p:cNvPr>
+          <p:cNvSpPr>
+            <a:spLocks noChangeArrowheads="1"/>
+          </p:cNvSpPr>
+          <p:nvPr/>
+        </p:nvSpPr>
+        <p:spPr bwMode="auto">
+          <a:xfrm>
+            <a:off x="1163782" y="2090172"/>
+            <a:ext cx="10257906" cy="2677656"/>
+          </a:xfrm>
+          <a:prstGeom prst="rect">
+            <a:avLst/>
+          </a:prstGeom>
+          <a:noFill/>
+          <a:ln>
+            <a:noFill/>
+          </a:ln>
+          <a:effectLst/>
+          <a:extLst>
+            <a:ext uri="{909E8E84-426E-40DD-AFC4-6F175D3DCCD1}">
+              <a14:hiddenFill xmlns:a14="http://schemas.microsoft.com/office/drawing/2010/main">
+                <a:solidFill>
+                  <a:schemeClr val="accent1"/>
+                </a:solidFill>
+              </a14:hiddenFill>
+            </a:ext>
+            <a:ext uri="{91240B29-F687-4F45-9708-019B960494DF}">
+              <a14:hiddenLine xmlns:a14="http://schemas.microsoft.com/office/drawing/2010/main" w="9525">
+                <a:solidFill>
+                  <a:schemeClr val="tx1"/>
+                </a:solidFill>
+                <a:miter lim="800000"/>
+                <a:headEnd/>
+                <a:tailEnd/>
+              </a14:hiddenLine>
+            </a:ext>
+            <a:ext uri="{AF507438-7753-43E0-B8FC-AC1667EBCBE1}">
+              <a14:hiddenEffects xmlns:a14="http://schemas.microsoft.com/office/drawing/2010/main">
+                <a:effectLst>
+                  <a:outerShdw dist="35921" dir="2700000" algn="ctr" rotWithShape="0">
+                    <a:schemeClr val="bg2"/>
+                  </a:outerShdw>
+                </a:effectLst>
+              </a14:hiddenEffects>
+            </a:ext>
+          </a:extLst>
+        </p:spPr>
+        <p:txBody>
+          <a:bodyPr vert="horz" wrap="square" lIns="91440" tIns="45720" rIns="91440" bIns="45720" numCol="1" anchor="ctr" anchorCtr="0" compatLnSpc="1">
+            <a:prstTxWarp prst="textNoShape">
+              <a:avLst/>
+            </a:prstTxWarp>
+            <a:spAutoFit/>
+          </a:bodyPr>
+          <a:lstStyle/>
+          <a:p>
+            <a:pPr marL="0" marR="0" lvl="0" indent="0" algn="l" defTabSz="914400" rtl="0" eaLnBrk="0" fontAlgn="base" latinLnBrk="0" hangingPunct="0">
+              <a:lnSpc>
+                <a:spcPct val="100000"/>
+              </a:lnSpc>
+              <a:spcBef>
+                <a:spcPct val="0"/>
+              </a:spcBef>
+              <a:spcAft>
+                <a:spcPct val="0"/>
+              </a:spcAft>
+              <a:buClrTx/>
+              <a:buSzTx/>
+              <a:buFontTx/>
+              <a:buChar char="•"/>
+              <a:tabLst/>
+            </a:pPr>
+            <a:r>
+              <a:rPr kumimoji="0" lang="en-US" altLang="en-US" sz="2400" b="0" i="0" u="none" strike="noStrike" cap="none" normalizeH="0" baseline="0" dirty="0">
+                <a:ln>
+                  <a:noFill/>
+                </a:ln>
+                <a:solidFill>
+                  <a:schemeClr val="tx1"/>
+                </a:solidFill>
+                <a:effectLst/>
+                <a:latin typeface="Arial" panose="020B0604020202020204" pitchFamily="34" charset="0"/>
+              </a:rPr>
+              <a:t> For the Ames Housing dataset:</a:t>
+            </a:r>
+          </a:p>
+          <a:p>
+            <a:pPr marL="0" marR="0" lvl="0" indent="0" algn="l" defTabSz="914400" rtl="0" eaLnBrk="0" fontAlgn="base" latinLnBrk="0" hangingPunct="0">
+              <a:lnSpc>
+                <a:spcPct val="100000"/>
+              </a:lnSpc>
+              <a:spcBef>
+                <a:spcPct val="0"/>
+              </a:spcBef>
+              <a:spcAft>
+                <a:spcPct val="0"/>
+              </a:spcAft>
+              <a:buClrTx/>
+              <a:buSzTx/>
+              <a:buFontTx/>
+              <a:buChar char="•"/>
+              <a:tabLst/>
+            </a:pPr>
+            <a:r>
+              <a:rPr kumimoji="0" lang="en-US" altLang="en-US" sz="2400" b="0" i="0" u="none" strike="noStrike" cap="none" normalizeH="0" baseline="0" dirty="0">
+                <a:ln>
+                  <a:noFill/>
+                </a:ln>
+                <a:solidFill>
+                  <a:schemeClr val="tx1"/>
+                </a:solidFill>
+                <a:effectLst/>
+                <a:latin typeface="Arial" panose="020B0604020202020204" pitchFamily="34" charset="0"/>
+              </a:rPr>
+              <a:t> Typical Linear Regression R² ranges from </a:t>
+            </a:r>
+            <a:r>
+              <a:rPr kumimoji="0" lang="en-US" altLang="en-US" sz="2400" b="1" i="0" u="none" strike="noStrike" cap="none" normalizeH="0" baseline="0" dirty="0">
+                <a:ln>
+                  <a:noFill/>
+                </a:ln>
+                <a:solidFill>
+                  <a:schemeClr val="tx1"/>
+                </a:solidFill>
+                <a:effectLst/>
+                <a:latin typeface="Arial" panose="020B0604020202020204" pitchFamily="34" charset="0"/>
+              </a:rPr>
+              <a:t>0.75 to 0.85</a:t>
+            </a:r>
+            <a:endParaRPr kumimoji="0" lang="en-US" altLang="en-US" sz="2400" b="0" i="0" u="none" strike="noStrike" cap="none" normalizeH="0" baseline="0" dirty="0">
+              <a:ln>
+                <a:noFill/>
+              </a:ln>
+              <a:solidFill>
+                <a:schemeClr val="tx1"/>
+              </a:solidFill>
+              <a:effectLst/>
+              <a:latin typeface="Arial" panose="020B0604020202020204" pitchFamily="34" charset="0"/>
+            </a:endParaRPr>
+          </a:p>
+          <a:p>
+            <a:pPr marL="0" marR="0" lvl="0" indent="0" algn="l" defTabSz="914400" rtl="0" eaLnBrk="0" fontAlgn="base" latinLnBrk="0" hangingPunct="0">
+              <a:lnSpc>
+                <a:spcPct val="100000"/>
+              </a:lnSpc>
+              <a:spcBef>
+                <a:spcPct val="0"/>
+              </a:spcBef>
+              <a:spcAft>
+                <a:spcPct val="0"/>
+              </a:spcAft>
+              <a:buClrTx/>
+              <a:buSzTx/>
+              <a:buFontTx/>
+              <a:buChar char="•"/>
+              <a:tabLst/>
+            </a:pPr>
+            <a:r>
+              <a:rPr kumimoji="0" lang="en-US" altLang="en-US" sz="2400" b="0" i="0" u="none" strike="noStrike" cap="none" normalizeH="0" baseline="0" dirty="0">
+                <a:ln>
+                  <a:noFill/>
+                </a:ln>
+                <a:solidFill>
+                  <a:schemeClr val="tx1"/>
+                </a:solidFill>
+                <a:effectLst/>
+                <a:latin typeface="Arial" panose="020B0604020202020204" pitchFamily="34" charset="0"/>
+              </a:rPr>
+              <a:t> Our model falls </a:t>
+            </a:r>
+            <a:r>
+              <a:rPr kumimoji="0" lang="en-US" altLang="en-US" sz="2400" b="1" i="0" u="none" strike="noStrike" cap="none" normalizeH="0" baseline="0" dirty="0">
+                <a:ln>
+                  <a:noFill/>
+                </a:ln>
+                <a:solidFill>
+                  <a:schemeClr val="tx1"/>
+                </a:solidFill>
+                <a:effectLst/>
+                <a:latin typeface="Arial" panose="020B0604020202020204" pitchFamily="34" charset="0"/>
+              </a:rPr>
+              <a:t>within the expected range</a:t>
+            </a:r>
+            <a:r>
+              <a:rPr kumimoji="0" lang="en-US" altLang="en-US" sz="2400" b="0" i="0" u="none" strike="noStrike" cap="none" normalizeH="0" baseline="0" dirty="0">
+                <a:ln>
+                  <a:noFill/>
+                </a:ln>
+                <a:solidFill>
+                  <a:schemeClr val="tx1"/>
+                </a:solidFill>
+                <a:effectLst/>
+                <a:latin typeface="Arial" panose="020B0604020202020204" pitchFamily="34" charset="0"/>
+              </a:rPr>
+              <a:t>.</a:t>
+            </a:r>
+          </a:p>
+          <a:p>
+            <a:pPr marL="0" marR="0" lvl="0" indent="0" algn="l" defTabSz="914400" rtl="0" eaLnBrk="0" fontAlgn="base" latinLnBrk="0" hangingPunct="0">
+              <a:lnSpc>
+                <a:spcPct val="100000"/>
+              </a:lnSpc>
+              <a:spcBef>
+                <a:spcPct val="0"/>
+              </a:spcBef>
+              <a:spcAft>
+                <a:spcPct val="0"/>
+              </a:spcAft>
+              <a:buClrTx/>
+              <a:buSzTx/>
+              <a:buFontTx/>
+              <a:buChar char="•"/>
+              <a:tabLst/>
+            </a:pPr>
+            <a:r>
+              <a:rPr kumimoji="0" lang="en-US" altLang="en-US" sz="2400" b="0" i="0" u="none" strike="noStrike" cap="none" normalizeH="0" baseline="0" dirty="0">
+                <a:ln>
+                  <a:noFill/>
+                </a:ln>
+                <a:solidFill>
+                  <a:schemeClr val="tx1"/>
+                </a:solidFill>
+                <a:effectLst/>
+                <a:latin typeface="Arial" panose="020B0604020202020204" pitchFamily="34" charset="0"/>
+              </a:rPr>
+              <a:t> Higher accuracy models (Random Forest, </a:t>
+            </a:r>
+            <a:r>
+              <a:rPr kumimoji="0" lang="en-US" altLang="en-US" sz="2400" b="0" i="0" u="none" strike="noStrike" cap="none" normalizeH="0" baseline="0" dirty="0" err="1">
+                <a:ln>
+                  <a:noFill/>
+                </a:ln>
+                <a:solidFill>
+                  <a:schemeClr val="tx1"/>
+                </a:solidFill>
+                <a:effectLst/>
+                <a:latin typeface="Arial" panose="020B0604020202020204" pitchFamily="34" charset="0"/>
+              </a:rPr>
+              <a:t>XGBoost</a:t>
+            </a:r>
+            <a:r>
+              <a:rPr kumimoji="0" lang="en-US" altLang="en-US" sz="2400" b="0" i="0" u="none" strike="noStrike" cap="none" normalizeH="0" baseline="0" dirty="0">
+                <a:ln>
+                  <a:noFill/>
+                </a:ln>
+                <a:solidFill>
+                  <a:schemeClr val="tx1"/>
+                </a:solidFill>
+                <a:effectLst/>
+                <a:latin typeface="Arial" panose="020B0604020202020204" pitchFamily="34" charset="0"/>
+              </a:rPr>
+              <a:t>) exist, but:</a:t>
+            </a:r>
+          </a:p>
+          <a:p>
+            <a:pPr marL="0" marR="0" lvl="0" indent="0" algn="l" defTabSz="914400" rtl="0" eaLnBrk="0" fontAlgn="base" latinLnBrk="0" hangingPunct="0">
+              <a:lnSpc>
+                <a:spcPct val="100000"/>
+              </a:lnSpc>
+              <a:spcBef>
+                <a:spcPct val="0"/>
+              </a:spcBef>
+              <a:spcAft>
+                <a:spcPct val="0"/>
+              </a:spcAft>
+              <a:buClrTx/>
+              <a:buSzTx/>
+              <a:buFontTx/>
+              <a:buChar char="•"/>
+              <a:tabLst/>
+            </a:pPr>
+            <a:r>
+              <a:rPr kumimoji="0" lang="en-US" altLang="en-US" sz="2400" b="0" i="0" u="none" strike="noStrike" cap="none" normalizeH="0" baseline="0" dirty="0">
+                <a:ln>
+                  <a:noFill/>
+                </a:ln>
+                <a:solidFill>
+                  <a:schemeClr val="tx1"/>
+                </a:solidFill>
+                <a:effectLst/>
+                <a:latin typeface="Arial" panose="020B0604020202020204" pitchFamily="34" charset="0"/>
+              </a:rPr>
+              <a:t> Linear Regression is chosen for </a:t>
+            </a:r>
+            <a:r>
+              <a:rPr kumimoji="0" lang="en-US" altLang="en-US" sz="2400" b="1" i="0" u="none" strike="noStrike" cap="none" normalizeH="0" baseline="0" dirty="0">
+                <a:ln>
+                  <a:noFill/>
+                </a:ln>
+                <a:solidFill>
+                  <a:schemeClr val="tx1"/>
+                </a:solidFill>
+                <a:effectLst/>
+                <a:latin typeface="Arial" panose="020B0604020202020204" pitchFamily="34" charset="0"/>
+              </a:rPr>
+              <a:t>simplicity, interpretability, and academic clarity</a:t>
+            </a:r>
+            <a:r>
+              <a:rPr kumimoji="0" lang="en-US" altLang="en-US" sz="2400" b="0" i="0" u="none" strike="noStrike" cap="none" normalizeH="0" baseline="0" dirty="0">
+                <a:ln>
+                  <a:noFill/>
+                </a:ln>
+                <a:solidFill>
+                  <a:schemeClr val="tx1"/>
+                </a:solidFill>
+                <a:effectLst/>
+                <a:latin typeface="Arial" panose="020B0604020202020204" pitchFamily="34" charset="0"/>
+              </a:rPr>
+              <a:t>.</a:t>
+            </a:r>
+          </a:p>
+          <a:p>
+            <a:pPr marL="0" marR="0" lvl="0" indent="0" algn="l" defTabSz="914400" rtl="0" eaLnBrk="0" fontAlgn="base" latinLnBrk="0" hangingPunct="0">
+              <a:lnSpc>
+                <a:spcPct val="100000"/>
+              </a:lnSpc>
+              <a:spcBef>
+                <a:spcPct val="0"/>
+              </a:spcBef>
+              <a:spcAft>
+                <a:spcPct val="0"/>
+              </a:spcAft>
+              <a:buClrTx/>
+              <a:buSzTx/>
+              <a:buFontTx/>
               <a:buNone/>
               <a:tabLst/>
             </a:pPr>
@@ -4959,62 +6315,15 @@
                 <a:schemeClr val="tx1"/>
               </a:solidFill>
               <a:effectLst/>
-              <a:latin typeface="Arial Nova" panose="020B0504020202020204" pitchFamily="34" charset="0"/>
+              <a:latin typeface="Arial" panose="020B0604020202020204" pitchFamily="34" charset="0"/>
             </a:endParaRPr>
           </a:p>
         </p:txBody>
       </p:sp>
-      <p:pic>
-        <p:nvPicPr>
-          <p:cNvPr id="3106" name="Picture 34">
-            <a:extLst>
-              <a:ext uri="{FF2B5EF4-FFF2-40B4-BE49-F238E27FC236}">
-                <a16:creationId xmlns:a16="http://schemas.microsoft.com/office/drawing/2014/main" id="{A1A8B6F8-D283-920F-E5E8-5F308BB392C6}"/>
-              </a:ext>
-            </a:extLst>
-          </p:cNvPr>
-          <p:cNvPicPr>
-            <a:picLocks noChangeAspect="1" noChangeArrowheads="1"/>
-          </p:cNvPicPr>
-          <p:nvPr/>
-        </p:nvPicPr>
-        <p:blipFill>
-          <a:blip r:embed="rId2">
-            <a:extLst>
-              <a:ext uri="{28A0092B-C50C-407E-A947-70E740481C1C}">
-                <a14:useLocalDpi xmlns:a14="http://schemas.microsoft.com/office/drawing/2010/main" val="0"/>
-              </a:ext>
-            </a:extLst>
-          </a:blip>
-          <a:srcRect/>
-          <a:stretch>
-            <a:fillRect/>
-          </a:stretch>
-        </p:blipFill>
-        <p:spPr bwMode="auto">
-          <a:xfrm>
-            <a:off x="6091238" y="3424238"/>
-            <a:ext cx="9525" cy="9525"/>
-          </a:xfrm>
-          <a:prstGeom prst="rect">
-            <a:avLst/>
-          </a:prstGeom>
-          <a:noFill/>
-          <a:extLst>
-            <a:ext uri="{909E8E84-426E-40DD-AFC4-6F175D3DCCD1}">
-              <a14:hiddenFill xmlns:a14="http://schemas.microsoft.com/office/drawing/2010/main">
-                <a:solidFill>
-                  <a:srgbClr val="FFFFFF"/>
-                </a:solidFill>
-              </a14:hiddenFill>
-            </a:ext>
-          </a:extLst>
-        </p:spPr>
-      </p:pic>
     </p:spTree>
     <p:extLst>
       <p:ext uri="{BB962C8B-B14F-4D97-AF65-F5344CB8AC3E}">
-        <p14:creationId xmlns:p14="http://schemas.microsoft.com/office/powerpoint/2010/main" val="2025344923"/>
+        <p14:creationId xmlns:p14="http://schemas.microsoft.com/office/powerpoint/2010/main" val="3130220329"/>
       </p:ext>
     </p:extLst>
   </p:cSld>

</xml_diff>